<commit_message>
feat: rename NormaTech + slot 8 manual no ALTEC-PEQUENO (pre-parcela C)
- App renomeado de Certificados NR para NormaTech (classe, titulo, toast)
- ALTEC_PEQUENO.pptx: usuario adicionou shapes do 8o cartao (ainda nomeados
  CARD7_*, correcao vem no proximo commit) + backup ALTEC_PEQUENO_OLD.pptx
- backups/ adicionado ao .gitignore
</commit_message>
<xml_diff>
--- a/templates/cards/pptx/ALTEC_PEQUENO.pptx
+++ b/templates/cards/pptx/ALTEC_PEQUENO.pptx
@@ -231,7 +231,7 @@
           <a:p>
             <a:fld id="{9D41C345-438A-4B3C-AC25-48B94D803C0B}" type="datetimeFigureOut">
               <a:rPr lang="pt-BR" smtClean="0"/>
-              <a:t>19/05/2026</a:t>
+              <a:t>01/09/2026</a:t>
             </a:fld>
             <a:endParaRPr lang="pt-BR"/>
           </a:p>
@@ -295,38 +295,37 @@
           <a:p>
             <a:pPr lvl="0"/>
             <a:r>
-              <a:rPr lang="pt-BR" smtClean="0"/>
+              <a:rPr lang="pt-BR"/>
               <a:t>Editar estilos de texto Mestre</a:t>
             </a:r>
           </a:p>
           <a:p>
             <a:pPr lvl="1"/>
             <a:r>
-              <a:rPr lang="pt-BR" smtClean="0"/>
+              <a:rPr lang="pt-BR"/>
               <a:t>Segundo nível</a:t>
             </a:r>
           </a:p>
           <a:p>
             <a:pPr lvl="2"/>
             <a:r>
-              <a:rPr lang="pt-BR" smtClean="0"/>
+              <a:rPr lang="pt-BR"/>
               <a:t>Terceiro nível</a:t>
             </a:r>
           </a:p>
           <a:p>
             <a:pPr lvl="3"/>
             <a:r>
-              <a:rPr lang="pt-BR" smtClean="0"/>
+              <a:rPr lang="pt-BR"/>
               <a:t>Quarto nível</a:t>
             </a:r>
           </a:p>
           <a:p>
             <a:pPr lvl="4"/>
             <a:r>
-              <a:rPr lang="pt-BR" smtClean="0"/>
+              <a:rPr lang="pt-BR"/>
               <a:t>Quinto nível</a:t>
             </a:r>
-            <a:endParaRPr lang="pt-BR"/>
           </a:p>
         </p:txBody>
       </p:sp>
@@ -762,7 +761,7 @@
           <a:p>
             <a:fld id="{7DACA480-7BCF-4C59-BED8-37E8E33A14D0}" type="datetimeFigureOut">
               <a:rPr lang="pt-BR" smtClean="0"/>
-              <a:t>19/05/2026</a:t>
+              <a:t>01/09/2026</a:t>
             </a:fld>
             <a:endParaRPr lang="pt-BR"/>
           </a:p>
@@ -930,7 +929,7 @@
           <a:p>
             <a:fld id="{7DACA480-7BCF-4C59-BED8-37E8E33A14D0}" type="datetimeFigureOut">
               <a:rPr lang="pt-BR" smtClean="0"/>
-              <a:t>19/05/2026</a:t>
+              <a:t>01/09/2026</a:t>
             </a:fld>
             <a:endParaRPr lang="pt-BR"/>
           </a:p>
@@ -1108,7 +1107,7 @@
           <a:p>
             <a:fld id="{7DACA480-7BCF-4C59-BED8-37E8E33A14D0}" type="datetimeFigureOut">
               <a:rPr lang="pt-BR" smtClean="0"/>
-              <a:t>19/05/2026</a:t>
+              <a:t>01/09/2026</a:t>
             </a:fld>
             <a:endParaRPr lang="pt-BR"/>
           </a:p>
@@ -1276,7 +1275,7 @@
           <a:p>
             <a:fld id="{7DACA480-7BCF-4C59-BED8-37E8E33A14D0}" type="datetimeFigureOut">
               <a:rPr lang="pt-BR" smtClean="0"/>
-              <a:t>19/05/2026</a:t>
+              <a:t>01/09/2026</a:t>
             </a:fld>
             <a:endParaRPr lang="pt-BR"/>
           </a:p>
@@ -1521,7 +1520,7 @@
           <a:p>
             <a:fld id="{7DACA480-7BCF-4C59-BED8-37E8E33A14D0}" type="datetimeFigureOut">
               <a:rPr lang="pt-BR" smtClean="0"/>
-              <a:t>19/05/2026</a:t>
+              <a:t>01/09/2026</a:t>
             </a:fld>
             <a:endParaRPr lang="pt-BR"/>
           </a:p>
@@ -1806,7 +1805,7 @@
           <a:p>
             <a:fld id="{7DACA480-7BCF-4C59-BED8-37E8E33A14D0}" type="datetimeFigureOut">
               <a:rPr lang="pt-BR" smtClean="0"/>
-              <a:t>19/05/2026</a:t>
+              <a:t>01/09/2026</a:t>
             </a:fld>
             <a:endParaRPr lang="pt-BR"/>
           </a:p>
@@ -2225,7 +2224,7 @@
           <a:p>
             <a:fld id="{7DACA480-7BCF-4C59-BED8-37E8E33A14D0}" type="datetimeFigureOut">
               <a:rPr lang="pt-BR" smtClean="0"/>
-              <a:t>19/05/2026</a:t>
+              <a:t>01/09/2026</a:t>
             </a:fld>
             <a:endParaRPr lang="pt-BR"/>
           </a:p>
@@ -2342,7 +2341,7 @@
           <a:p>
             <a:fld id="{7DACA480-7BCF-4C59-BED8-37E8E33A14D0}" type="datetimeFigureOut">
               <a:rPr lang="pt-BR" smtClean="0"/>
-              <a:t>19/05/2026</a:t>
+              <a:t>01/09/2026</a:t>
             </a:fld>
             <a:endParaRPr lang="pt-BR"/>
           </a:p>
@@ -2437,7 +2436,7 @@
           <a:p>
             <a:fld id="{7DACA480-7BCF-4C59-BED8-37E8E33A14D0}" type="datetimeFigureOut">
               <a:rPr lang="pt-BR" smtClean="0"/>
-              <a:t>19/05/2026</a:t>
+              <a:t>01/09/2026</a:t>
             </a:fld>
             <a:endParaRPr lang="pt-BR"/>
           </a:p>
@@ -2712,7 +2711,7 @@
           <a:p>
             <a:fld id="{7DACA480-7BCF-4C59-BED8-37E8E33A14D0}" type="datetimeFigureOut">
               <a:rPr lang="pt-BR" smtClean="0"/>
-              <a:t>19/05/2026</a:t>
+              <a:t>01/09/2026</a:t>
             </a:fld>
             <a:endParaRPr lang="pt-BR"/>
           </a:p>
@@ -2964,7 +2963,7 @@
           <a:p>
             <a:fld id="{7DACA480-7BCF-4C59-BED8-37E8E33A14D0}" type="datetimeFigureOut">
               <a:rPr lang="pt-BR" smtClean="0"/>
-              <a:t>19/05/2026</a:t>
+              <a:t>01/09/2026</a:t>
             </a:fld>
             <a:endParaRPr lang="pt-BR"/>
           </a:p>
@@ -3175,7 +3174,7 @@
           <a:p>
             <a:fld id="{7DACA480-7BCF-4C59-BED8-37E8E33A14D0}" type="datetimeFigureOut">
               <a:rPr lang="pt-BR" smtClean="0"/>
-              <a:t>19/05/2026</a:t>
+              <a:t>01/09/2026</a:t>
             </a:fld>
             <a:endParaRPr lang="pt-BR"/>
           </a:p>
@@ -3604,14 +3603,7 @@
           <a:lstStyle/>
           <a:p>
             <a:pPr algn="ctr"/>
-            <a:r>
-              <a:rPr lang="pt-BR" dirty="0" err="1"/>
-              <a:t/>
-            </a:r>
-            <a:r>
-              <a:rPr lang="pt-BR" dirty="0"/>
-              <a:t/>
-            </a:r>
+            <a:endParaRPr/>
           </a:p>
         </p:txBody>
       </p:sp>
@@ -3671,10 +3663,6 @@
           </a:p>
           <a:p>
             <a:pPr algn="ctr"/>
-            <a:r>
-              <a:rPr lang="pt-BR" dirty="0" smtClean="0"/>
-              <a:t/>
-            </a:r>
             <a:endParaRPr lang="pt-BR" dirty="0"/>
           </a:p>
         </p:txBody>
@@ -3779,14 +3767,7 @@
           <a:lstStyle/>
           <a:p>
             <a:pPr algn="ctr"/>
-            <a:r>
-              <a:rPr lang="pt-BR" dirty="0" err="1"/>
-              <a:t/>
-            </a:r>
-            <a:r>
-              <a:rPr lang="pt-BR" dirty="0"/>
-              <a:t/>
-            </a:r>
+            <a:endParaRPr/>
           </a:p>
         </p:txBody>
       </p:sp>
@@ -4088,7 +4069,7 @@
         </p:blipFill>
         <p:spPr>
           <a:xfrm>
-            <a:off x="2766502" y="3588716"/>
+            <a:off x="2766998" y="3559888"/>
             <a:ext cx="330044" cy="324000"/>
           </a:xfrm>
           <a:prstGeom prst="rect">
@@ -4118,7 +4099,7 @@
         </p:blipFill>
         <p:spPr>
           <a:xfrm>
-            <a:off x="4704004" y="3605203"/>
+            <a:off x="4704004" y="3562925"/>
             <a:ext cx="330044" cy="324000"/>
           </a:xfrm>
           <a:prstGeom prst="rect">
@@ -4328,7 +4309,7 @@
         </p:blipFill>
         <p:spPr>
           <a:xfrm>
-            <a:off x="5505962" y="3597691"/>
+            <a:off x="5507251" y="3561053"/>
             <a:ext cx="837000" cy="324000"/>
           </a:xfrm>
           <a:prstGeom prst="rect">
@@ -4358,7 +4339,7 @@
         </p:blipFill>
         <p:spPr>
           <a:xfrm>
-            <a:off x="7393776" y="3605203"/>
+            <a:off x="7393776" y="3563470"/>
             <a:ext cx="837000" cy="324000"/>
           </a:xfrm>
           <a:prstGeom prst="rect">
@@ -4404,13 +4385,15 @@
       <p:cxnSp>
         <p:nvCxnSpPr>
           <p:cNvPr id="63" name="Conector reto 62"/>
-          <p:cNvCxnSpPr/>
+          <p:cNvCxnSpPr>
+            <a:cxnSpLocks/>
+          </p:cNvCxnSpPr>
           <p:nvPr/>
         </p:nvCxnSpPr>
         <p:spPr>
           <a:xfrm>
             <a:off x="784890" y="2519055"/>
-            <a:ext cx="1772382" cy="0"/>
+            <a:ext cx="1800000" cy="0"/>
           </a:xfrm>
           <a:prstGeom prst="line">
             <a:avLst/>
@@ -4474,13 +4457,15 @@
       <p:cxnSp>
         <p:nvCxnSpPr>
           <p:cNvPr id="71" name="Conector reto 70"/>
-          <p:cNvCxnSpPr/>
+          <p:cNvCxnSpPr>
+            <a:cxnSpLocks/>
+          </p:cNvCxnSpPr>
           <p:nvPr/>
         </p:nvCxnSpPr>
         <p:spPr>
           <a:xfrm>
-            <a:off x="2708387" y="2540195"/>
-            <a:ext cx="1772382" cy="0"/>
+            <a:off x="2680769" y="2540195"/>
+            <a:ext cx="1800000" cy="0"/>
           </a:xfrm>
           <a:prstGeom prst="line">
             <a:avLst/>
@@ -4509,13 +4494,15 @@
       <p:cxnSp>
         <p:nvCxnSpPr>
           <p:cNvPr id="76" name="Conector reto 75"/>
-          <p:cNvCxnSpPr/>
+          <p:cNvCxnSpPr>
+            <a:cxnSpLocks/>
+          </p:cNvCxnSpPr>
           <p:nvPr/>
         </p:nvCxnSpPr>
         <p:spPr>
           <a:xfrm>
-            <a:off x="4547165" y="2555853"/>
-            <a:ext cx="1800000" cy="0"/>
+            <a:off x="4572000" y="2555853"/>
+            <a:ext cx="1795463" cy="0"/>
           </a:xfrm>
           <a:prstGeom prst="line">
             <a:avLst/>
@@ -4544,12 +4531,16 @@
       <p:cxnSp>
         <p:nvCxnSpPr>
           <p:cNvPr id="77" name="Conector reto 76"/>
-          <p:cNvCxnSpPr/>
+          <p:cNvCxnSpPr>
+            <a:cxnSpLocks/>
+            <a:stCxn id="31" idx="1"/>
+            <a:endCxn id="31" idx="3"/>
+          </p:cNvCxnSpPr>
           <p:nvPr/>
         </p:nvCxnSpPr>
         <p:spPr>
           <a:xfrm>
-            <a:off x="4547165" y="1839542"/>
+            <a:off x="4576559" y="1839542"/>
             <a:ext cx="1800000" cy="0"/>
           </a:xfrm>
           <a:prstGeom prst="line">
@@ -4694,7 +4685,7 @@
           <a:lstStyle/>
           <a:p>
             <a:pPr algn="ctr"/>
-            <a:endParaRPr lang="pt-BR" sz="1200" b="1" dirty="0" smtClean="0">
+            <a:endParaRPr lang="pt-BR" sz="1200" b="1" dirty="0">
               <a:solidFill>
                 <a:schemeClr val="tx1"/>
               </a:solidFill>
@@ -4710,7 +4701,7 @@
           </a:p>
           <a:p>
             <a:pPr algn="ctr"/>
-            <a:endParaRPr lang="pt-BR" sz="1200" b="1" dirty="0" smtClean="0">
+            <a:endParaRPr lang="pt-BR" sz="1200" b="1" dirty="0">
               <a:solidFill>
                 <a:schemeClr val="tx1"/>
               </a:solidFill>
@@ -4726,7 +4717,7 @@
           </a:p>
           <a:p>
             <a:pPr algn="ctr"/>
-            <a:endParaRPr lang="pt-BR" sz="1200" b="1" dirty="0" smtClean="0">
+            <a:endParaRPr lang="pt-BR" sz="1200" b="1" dirty="0">
               <a:solidFill>
                 <a:schemeClr val="tx1"/>
               </a:solidFill>
@@ -4764,7 +4755,7 @@
         </p:blipFill>
         <p:spPr>
           <a:xfrm>
-            <a:off x="873372" y="3577742"/>
+            <a:off x="882148" y="3566402"/>
             <a:ext cx="330044" cy="324000"/>
           </a:xfrm>
           <a:prstGeom prst="rect">
@@ -4794,7 +4785,7 @@
         </p:blipFill>
         <p:spPr>
           <a:xfrm>
-            <a:off x="1587053" y="3588716"/>
+            <a:off x="1596404" y="3559888"/>
             <a:ext cx="837000" cy="324000"/>
           </a:xfrm>
           <a:prstGeom prst="rect">
@@ -4826,28 +4817,15 @@
             <a:pPr algn="ctr"/>
             <a:r>
               <a:rPr lang="pt-BR" sz="1200" b="1" dirty="0"/>
-              <a:t>MANUTENÇÃO EM </a:t>
-            </a:r>
-            <a:r>
-              <a:rPr lang="pt-BR" sz="1200" b="1" dirty="0" smtClean="0"/>
-              <a:t>EQUIPAMENTO</a:t>
+              <a:t>MANUTENÇÃO EM EQUIPAMENTO</a:t>
             </a:r>
           </a:p>
           <a:p>
             <a:pPr algn="ctr"/>
             <a:r>
-              <a:rPr lang="pt-BR" sz="1200" b="1" dirty="0" smtClean="0"/>
-              <a:t> </a:t>
-            </a:r>
-            <a:r>
               <a:rPr lang="pt-BR" sz="1200" b="1" dirty="0"/>
-              <a:t>NÃO </a:t>
-            </a:r>
-            <a:r>
-              <a:rPr lang="pt-BR" sz="1200" b="1" dirty="0" smtClean="0"/>
-              <a:t>LIGUE</a:t>
-            </a:r>
-            <a:endParaRPr lang="pt-BR" sz="1200" b="1" dirty="0"/>
+              <a:t> NÃO LIGUE</a:t>
+            </a:r>
           </a:p>
         </p:txBody>
       </p:sp>
@@ -4889,13 +4867,15 @@
       <p:cxnSp>
         <p:nvCxnSpPr>
           <p:cNvPr id="95" name="Conector reto 94"/>
-          <p:cNvCxnSpPr/>
+          <p:cNvCxnSpPr>
+            <a:cxnSpLocks/>
+          </p:cNvCxnSpPr>
           <p:nvPr/>
         </p:nvCxnSpPr>
         <p:spPr>
           <a:xfrm>
-            <a:off x="4576559" y="5555617"/>
-            <a:ext cx="1800000" cy="0"/>
+            <a:off x="4615336" y="5555617"/>
+            <a:ext cx="1790626" cy="0"/>
           </a:xfrm>
           <a:prstGeom prst="line">
             <a:avLst/>
@@ -5139,8 +5119,94 @@
         </p:nvSpPr>
         <p:spPr>
           <a:xfrm>
-            <a:off x="763090" y="2511706"/>
-            <a:ext cx="1924053" cy="276999"/>
+            <a:off x="815975" y="2511706"/>
+            <a:ext cx="1871168" cy="215444"/>
+          </a:xfrm>
+          <a:prstGeom prst="rect">
+            <a:avLst/>
+          </a:prstGeom>
+        </p:spPr>
+        <p:txBody>
+          <a:bodyPr wrap="square">
+            <a:spAutoFit/>
+          </a:bodyPr>
+          <a:lstStyle/>
+          <a:p>
+            <a:r>
+              <a:rPr lang="pt-BR" sz="800" dirty="0"/>
+              <a:t>{{NOME}}</a:t>
+            </a:r>
+          </a:p>
+        </p:txBody>
+      </p:sp>
+      <p:sp>
+        <p:nvSpPr>
+          <p:cNvPr id="90" name="CARD2_NOME"/>
+          <p:cNvSpPr/>
+          <p:nvPr/>
+        </p:nvSpPr>
+        <p:spPr>
+          <a:xfrm>
+            <a:off x="2723405" y="2516043"/>
+            <a:ext cx="1283401" cy="215444"/>
+          </a:xfrm>
+          <a:prstGeom prst="rect">
+            <a:avLst/>
+          </a:prstGeom>
+        </p:spPr>
+        <p:txBody>
+          <a:bodyPr wrap="square">
+            <a:spAutoFit/>
+          </a:bodyPr>
+          <a:lstStyle/>
+          <a:p>
+            <a:r>
+              <a:rPr lang="pt-BR" sz="800" dirty="0"/>
+              <a:t>{{NOME}}</a:t>
+            </a:r>
+            <a:endParaRPr lang="pt-BR" sz="1200" dirty="0"/>
+          </a:p>
+        </p:txBody>
+      </p:sp>
+      <p:sp>
+        <p:nvSpPr>
+          <p:cNvPr id="5" name="CARD1_FUNCAO"/>
+          <p:cNvSpPr/>
+          <p:nvPr/>
+        </p:nvSpPr>
+        <p:spPr>
+          <a:xfrm>
+            <a:off x="813729" y="2795361"/>
+            <a:ext cx="1760136" cy="207749"/>
+          </a:xfrm>
+          <a:prstGeom prst="rect">
+            <a:avLst/>
+          </a:prstGeom>
+        </p:spPr>
+        <p:txBody>
+          <a:bodyPr wrap="square">
+            <a:spAutoFit/>
+          </a:bodyPr>
+          <a:lstStyle/>
+          <a:p>
+            <a:r>
+              <a:rPr lang="pt-BR" sz="750" dirty="0"/>
+              <a:t>{{FUNCAO}}</a:t>
+            </a:r>
+            <a:endParaRPr lang="pt-BR" sz="1200" dirty="0"/>
+          </a:p>
+        </p:txBody>
+      </p:sp>
+      <p:sp>
+        <p:nvSpPr>
+          <p:cNvPr id="91" name="CARD3_NOME"/>
+          <p:cNvSpPr/>
+          <p:nvPr/>
+        </p:nvSpPr>
+        <p:spPr>
+          <a:xfrm>
+            <a:off x="4615336" y="2731487"/>
+            <a:ext cx="671979" cy="215444"/>
           </a:xfrm>
           <a:prstGeom prst="rect">
             <a:avLst/>
@@ -5153,34 +5219,109 @@
           <a:lstStyle/>
           <a:p>
             <a:r>
-              <a:rPr lang="pt-BR" sz="800" dirty="0" smtClean="0"/>
-              <a:t>{{NOME}}</a:t>
-            </a:r>
-            <a:r>
               <a:rPr lang="pt-BR" sz="800" dirty="0"/>
-              <a:t/>
-            </a:r>
-            <a:r>
-              <a:rPr lang="pt-BR" sz="800" dirty="0" smtClean="0"/>
-              <a:t/>
-            </a:r>
-            <a:r>
-              <a:rPr lang="pt-BR" sz="800" dirty="0"/>
-              <a:t/>
-            </a:r>
-          </a:p>
-        </p:txBody>
-      </p:sp>
-      <p:sp>
-        <p:nvSpPr>
-          <p:cNvPr id="90" name="CARD2_NOME"/>
+              <a:t>{{FUNCAO}}</a:t>
+            </a:r>
+          </a:p>
+        </p:txBody>
+      </p:sp>
+      <p:sp>
+        <p:nvSpPr>
+          <p:cNvPr id="92" name="CARD2_FUNCAO"/>
           <p:cNvSpPr/>
           <p:nvPr/>
         </p:nvSpPr>
         <p:spPr>
           <a:xfrm>
-            <a:off x="2944849" y="2516043"/>
-            <a:ext cx="1061957" cy="276999"/>
+            <a:off x="2723405" y="2795580"/>
+            <a:ext cx="1797027" cy="207749"/>
+          </a:xfrm>
+          <a:prstGeom prst="rect">
+            <a:avLst/>
+          </a:prstGeom>
+        </p:spPr>
+        <p:txBody>
+          <a:bodyPr wrap="square">
+            <a:spAutoFit/>
+          </a:bodyPr>
+          <a:lstStyle/>
+          <a:p>
+            <a:r>
+              <a:rPr lang="pt-BR" sz="750" dirty="0"/>
+              <a:t>{{FUNCAO}}</a:t>
+            </a:r>
+            <a:endParaRPr lang="pt-BR" sz="1200" dirty="0"/>
+          </a:p>
+        </p:txBody>
+      </p:sp>
+      <p:sp>
+        <p:nvSpPr>
+          <p:cNvPr id="6" name="CARD1_TELEFONE"/>
+          <p:cNvSpPr/>
+          <p:nvPr/>
+        </p:nvSpPr>
+        <p:spPr>
+          <a:xfrm>
+            <a:off x="813116" y="3005085"/>
+            <a:ext cx="1566576" cy="215444"/>
+          </a:xfrm>
+          <a:prstGeom prst="rect">
+            <a:avLst/>
+          </a:prstGeom>
+        </p:spPr>
+        <p:txBody>
+          <a:bodyPr wrap="square">
+            <a:spAutoFit/>
+          </a:bodyPr>
+          <a:lstStyle/>
+          <a:p>
+            <a:r>
+              <a:rPr lang="pt-BR" sz="800" dirty="0" err="1"/>
+              <a:t>{{TELEFONE}}</a:t>
+            </a:r>
+            <a:endParaRPr lang="pt-BR" sz="1200" dirty="0"/>
+          </a:p>
+        </p:txBody>
+      </p:sp>
+      <p:sp>
+        <p:nvSpPr>
+          <p:cNvPr id="102" name="CARD2_TELEFONE"/>
+          <p:cNvSpPr/>
+          <p:nvPr/>
+        </p:nvSpPr>
+        <p:spPr>
+          <a:xfrm>
+            <a:off x="2723405" y="3003110"/>
+            <a:ext cx="1518433" cy="215444"/>
+          </a:xfrm>
+          <a:prstGeom prst="rect">
+            <a:avLst/>
+          </a:prstGeom>
+        </p:spPr>
+        <p:txBody>
+          <a:bodyPr wrap="square">
+            <a:spAutoFit/>
+          </a:bodyPr>
+          <a:lstStyle/>
+          <a:p>
+            <a:r>
+              <a:rPr lang="pt-BR" sz="800" dirty="0" err="1"/>
+              <a:t>{{TELEFONE}}</a:t>
+            </a:r>
+            <a:endParaRPr lang="pt-BR" sz="1200" dirty="0"/>
+          </a:p>
+        </p:txBody>
+      </p:sp>
+      <p:sp>
+        <p:nvSpPr>
+          <p:cNvPr id="103" name="CARD3_TELEFONE"/>
+          <p:cNvSpPr/>
+          <p:nvPr/>
+        </p:nvSpPr>
+        <p:spPr>
+          <a:xfrm>
+            <a:off x="4615336" y="2949544"/>
+            <a:ext cx="1405321" cy="276999"/>
           </a:xfrm>
           <a:prstGeom prst="rect">
             <a:avLst/>
@@ -5193,8 +5334,8 @@
           <a:lstStyle/>
           <a:p>
             <a:r>
-              <a:rPr lang="pt-BR" sz="800" dirty="0" smtClean="0"/>
-              <a:t>{{NOME}}</a:t>
+              <a:rPr lang="pt-BR" sz="800" dirty="0" err="1"/>
+              <a:t>{{TELEFONE}}</a:t>
             </a:r>
             <a:endParaRPr lang="pt-BR" sz="1200" dirty="0"/>
           </a:p>
@@ -5202,14 +5343,14 @@
       </p:sp>
       <p:sp>
         <p:nvSpPr>
-          <p:cNvPr id="5" name="CARD1_FUNCAO"/>
+          <p:cNvPr id="8" name="CARD4_FUNCAO"/>
           <p:cNvSpPr/>
           <p:nvPr/>
         </p:nvSpPr>
         <p:spPr>
           <a:xfrm>
-            <a:off x="767474" y="2690600"/>
-            <a:ext cx="1808637" cy="276999"/>
+            <a:off x="6466476" y="2803299"/>
+            <a:ext cx="1797736" cy="276999"/>
           </a:xfrm>
           <a:prstGeom prst="rect">
             <a:avLst/>
@@ -5222,23 +5363,50 @@
           <a:lstStyle/>
           <a:p>
             <a:r>
-              <a:rPr lang="pt-BR" sz="750" dirty="0" smtClean="0"/>
+              <a:rPr lang="pt-BR" sz="750" dirty="0"/>
               <a:t>{{FUNCAO}}</a:t>
             </a:r>
-            <a:endParaRPr lang="pt-BR" sz="1200" dirty="0"/>
-          </a:p>
-        </p:txBody>
-      </p:sp>
-      <p:sp>
-        <p:nvSpPr>
-          <p:cNvPr id="91" name="CARD3_NOME"/>
+          </a:p>
+        </p:txBody>
+      </p:sp>
+      <p:sp>
+        <p:nvSpPr>
+          <p:cNvPr id="9" name="CARD4_TELEFONE"/>
           <p:cNvSpPr/>
           <p:nvPr/>
         </p:nvSpPr>
         <p:spPr>
           <a:xfrm>
-            <a:off x="4678838" y="2690600"/>
-            <a:ext cx="1509965" cy="276999"/>
+            <a:off x="6521422" y="3046102"/>
+            <a:ext cx="1570206" cy="215444"/>
+          </a:xfrm>
+          <a:prstGeom prst="rect">
+            <a:avLst/>
+          </a:prstGeom>
+        </p:spPr>
+        <p:txBody>
+          <a:bodyPr wrap="square">
+            <a:spAutoFit/>
+          </a:bodyPr>
+          <a:lstStyle/>
+          <a:p>
+            <a:r>
+              <a:rPr lang="pt-BR" sz="800" dirty="0" err="1"/>
+              <a:t>{{TELEFONE}}</a:t>
+            </a:r>
+          </a:p>
+        </p:txBody>
+      </p:sp>
+      <p:sp>
+        <p:nvSpPr>
+          <p:cNvPr id="10" name="CARD5_NOME"/>
+          <p:cNvSpPr/>
+          <p:nvPr/>
+        </p:nvSpPr>
+        <p:spPr>
+          <a:xfrm>
+            <a:off x="717506" y="5618422"/>
+            <a:ext cx="1898277" cy="276999"/>
           </a:xfrm>
           <a:prstGeom prst="rect">
             <a:avLst/>
@@ -5251,25 +5419,22 @@
           <a:lstStyle/>
           <a:p>
             <a:r>
-              <a:rPr lang="pt-BR" sz="800" dirty="0" smtClean="0"/>
+              <a:rPr lang="pt-BR" sz="800" dirty="0"/>
               <a:t>{{NOME}}</a:t>
             </a:r>
-            <a:r>
-              <a:rPr lang="pt-BR" sz="800" dirty="0"/>
-              <a:t/>
-            </a:r>
-          </a:p>
-        </p:txBody>
-      </p:sp>
-      <p:sp>
-        <p:nvSpPr>
-          <p:cNvPr id="92" name="CARD2_FUNCAO"/>
+            <a:endParaRPr lang="pt-BR" sz="1200" dirty="0"/>
+          </a:p>
+        </p:txBody>
+      </p:sp>
+      <p:sp>
+        <p:nvSpPr>
+          <p:cNvPr id="11" name="CARD5_FUNCAO"/>
           <p:cNvSpPr/>
           <p:nvPr/>
         </p:nvSpPr>
         <p:spPr>
           <a:xfrm>
-            <a:off x="2711795" y="2693543"/>
+            <a:off x="794878" y="5904967"/>
             <a:ext cx="1808637" cy="276999"/>
           </a:xfrm>
           <a:prstGeom prst="rect">
@@ -5283,23 +5448,22 @@
           <a:lstStyle/>
           <a:p>
             <a:r>
-              <a:rPr lang="pt-BR" sz="750" dirty="0" smtClean="0"/>
+              <a:rPr lang="pt-BR" sz="750" dirty="0"/>
               <a:t>{{FUNCAO}}</a:t>
             </a:r>
-            <a:endParaRPr lang="pt-BR" sz="1200" dirty="0"/>
-          </a:p>
-        </p:txBody>
-      </p:sp>
-      <p:sp>
-        <p:nvSpPr>
-          <p:cNvPr id="6" name="CARD1_TELEFONE"/>
+          </a:p>
+        </p:txBody>
+      </p:sp>
+      <p:sp>
+        <p:nvSpPr>
+          <p:cNvPr id="12" name="CARD5_TELEFONE"/>
           <p:cNvSpPr/>
           <p:nvPr/>
         </p:nvSpPr>
         <p:spPr>
           <a:xfrm>
-            <a:off x="966009" y="2890530"/>
-            <a:ext cx="1416542" cy="276999"/>
+            <a:off x="774546" y="6126033"/>
+            <a:ext cx="1381276" cy="276999"/>
           </a:xfrm>
           <a:prstGeom prst="rect">
             <a:avLst/>
@@ -5315,28 +5479,19 @@
               <a:rPr lang="pt-BR" sz="800" dirty="0" err="1"/>
               <a:t>{{TELEFONE}}</a:t>
             </a:r>
-            <a:r>
-              <a:rPr lang="pt-BR" sz="800" dirty="0"/>
-              <a:t/>
-            </a:r>
-            <a:r>
-              <a:rPr lang="pt-BR" sz="800" dirty="0" smtClean="0"/>
-              <a:t/>
-            </a:r>
-            <a:endParaRPr lang="pt-BR" sz="1200" dirty="0"/>
-          </a:p>
-        </p:txBody>
-      </p:sp>
-      <p:sp>
-        <p:nvSpPr>
-          <p:cNvPr id="102" name="CARD2_TELEFONE"/>
+          </a:p>
+        </p:txBody>
+      </p:sp>
+      <p:sp>
+        <p:nvSpPr>
+          <p:cNvPr id="73" name="CARD6_NOME"/>
           <p:cNvSpPr/>
           <p:nvPr/>
         </p:nvSpPr>
         <p:spPr>
           <a:xfrm>
-            <a:off x="2825296" y="2895518"/>
-            <a:ext cx="1416542" cy="276999"/>
+            <a:off x="2709021" y="5600445"/>
+            <a:ext cx="1061957" cy="276999"/>
           </a:xfrm>
           <a:prstGeom prst="rect">
             <a:avLst/>
@@ -5349,16 +5504,8 @@
           <a:lstStyle/>
           <a:p>
             <a:r>
-              <a:rPr lang="pt-BR" sz="800" dirty="0" err="1"/>
-              <a:t>{{TELEFONE}}</a:t>
-            </a:r>
-            <a:r>
               <a:rPr lang="pt-BR" sz="800" dirty="0"/>
-              <a:t/>
-            </a:r>
-            <a:r>
-              <a:rPr lang="pt-BR" sz="800" dirty="0" smtClean="0"/>
-              <a:t/>
+              <a:t>{{NOME}}</a:t>
             </a:r>
             <a:endParaRPr lang="pt-BR" sz="1200" dirty="0"/>
           </a:p>
@@ -5366,14 +5513,14 @@
       </p:sp>
       <p:sp>
         <p:nvSpPr>
-          <p:cNvPr id="103" name="CARD3_TELEFONE"/>
+          <p:cNvPr id="74" name="CARD6_FUNCAO"/>
           <p:cNvSpPr/>
           <p:nvPr/>
         </p:nvSpPr>
         <p:spPr>
           <a:xfrm>
-            <a:off x="4704004" y="2899444"/>
-            <a:ext cx="1405321" cy="276999"/>
+            <a:off x="2715116" y="5876976"/>
+            <a:ext cx="1808637" cy="276999"/>
           </a:xfrm>
           <a:prstGeom prst="rect">
             <a:avLst/>
@@ -5386,16 +5533,8 @@
           <a:lstStyle/>
           <a:p>
             <a:r>
-              <a:rPr lang="pt-BR" sz="800" dirty="0" err="1"/>
-              <a:t>{{TELEFONE}}</a:t>
-            </a:r>
-            <a:r>
-              <a:rPr lang="pt-BR" sz="800" dirty="0"/>
-              <a:t/>
-            </a:r>
-            <a:r>
-              <a:rPr lang="pt-BR" sz="800" dirty="0" smtClean="0"/>
-              <a:t/>
+              <a:rPr lang="pt-BR" sz="750" dirty="0"/>
+              <a:t>{{FUNCAO}}</a:t>
             </a:r>
             <a:endParaRPr lang="pt-BR" sz="1200" dirty="0"/>
           </a:p>
@@ -5403,14 +5542,14 @@
       </p:sp>
       <p:sp>
         <p:nvSpPr>
-          <p:cNvPr id="8" name="CARD4_FUNCAO"/>
+          <p:cNvPr id="75" name="CARD6_TELEFONE"/>
           <p:cNvSpPr/>
           <p:nvPr/>
         </p:nvSpPr>
         <p:spPr>
           <a:xfrm>
-            <a:off x="6455746" y="2758644"/>
-            <a:ext cx="1797736" cy="276999"/>
+            <a:off x="2716556" y="6116148"/>
+            <a:ext cx="1381276" cy="276999"/>
           </a:xfrm>
           <a:prstGeom prst="rect">
             <a:avLst/>
@@ -5423,22 +5562,231 @@
           <a:lstStyle/>
           <a:p>
             <a:r>
-              <a:rPr lang="pt-BR" sz="750" dirty="0"/>
-              <a:t>{{FUNCAO}}</a:t>
-            </a:r>
-          </a:p>
-        </p:txBody>
-      </p:sp>
-      <p:sp>
-        <p:nvSpPr>
-          <p:cNvPr id="9" name="CARD4_TELEFONE"/>
+              <a:rPr lang="pt-BR" sz="800" dirty="0" err="1"/>
+              <a:t>{{TELEFONE}}</a:t>
+            </a:r>
+          </a:p>
+        </p:txBody>
+      </p:sp>
+      <p:sp>
+        <p:nvSpPr>
+          <p:cNvPr id="89" name="Retângulo 88"/>
           <p:cNvSpPr/>
           <p:nvPr/>
         </p:nvSpPr>
         <p:spPr>
           <a:xfrm>
-            <a:off x="6675086" y="2913611"/>
-            <a:ext cx="1416542" cy="276999"/>
+            <a:off x="4591842" y="1870562"/>
+            <a:ext cx="1929580" cy="646331"/>
+          </a:xfrm>
+          <a:prstGeom prst="rect">
+            <a:avLst/>
+          </a:prstGeom>
+        </p:spPr>
+        <p:txBody>
+          <a:bodyPr wrap="square">
+            <a:spAutoFit/>
+          </a:bodyPr>
+          <a:lstStyle/>
+          <a:p>
+            <a:pPr algn="ctr"/>
+            <a:r>
+              <a:rPr lang="pt-BR" sz="1200" b="1" dirty="0"/>
+              <a:t>MANUTENÇÃO EM EQUIPAMENTO</a:t>
+            </a:r>
+          </a:p>
+          <a:p>
+            <a:pPr algn="ctr"/>
+            <a:r>
+              <a:rPr lang="pt-BR" sz="1200" b="1" dirty="0"/>
+              <a:t> NÃO LIGUE</a:t>
+            </a:r>
+          </a:p>
+        </p:txBody>
+      </p:sp>
+      <p:sp>
+        <p:nvSpPr>
+          <p:cNvPr id="93" name="Retângulo 92"/>
+          <p:cNvSpPr/>
+          <p:nvPr/>
+        </p:nvSpPr>
+        <p:spPr>
+          <a:xfrm>
+            <a:off x="703250" y="4943364"/>
+            <a:ext cx="1929580" cy="646331"/>
+          </a:xfrm>
+          <a:prstGeom prst="rect">
+            <a:avLst/>
+          </a:prstGeom>
+        </p:spPr>
+        <p:txBody>
+          <a:bodyPr wrap="square">
+            <a:spAutoFit/>
+          </a:bodyPr>
+          <a:lstStyle/>
+          <a:p>
+            <a:pPr algn="ctr"/>
+            <a:r>
+              <a:rPr lang="pt-BR" sz="1200" b="1" dirty="0"/>
+              <a:t>MANUTENÇÃO EM EQUIPAMENTO</a:t>
+            </a:r>
+          </a:p>
+          <a:p>
+            <a:pPr algn="ctr"/>
+            <a:r>
+              <a:rPr lang="pt-BR" sz="1200" b="1" dirty="0"/>
+              <a:t> NÃO LIGUE</a:t>
+            </a:r>
+          </a:p>
+        </p:txBody>
+      </p:sp>
+      <p:sp>
+        <p:nvSpPr>
+          <p:cNvPr id="105" name="Retângulo 104"/>
+          <p:cNvSpPr/>
+          <p:nvPr/>
+        </p:nvSpPr>
+        <p:spPr>
+          <a:xfrm>
+            <a:off x="2696162" y="1880649"/>
+            <a:ext cx="1929580" cy="646331"/>
+          </a:xfrm>
+          <a:prstGeom prst="rect">
+            <a:avLst/>
+          </a:prstGeom>
+        </p:spPr>
+        <p:txBody>
+          <a:bodyPr wrap="square">
+            <a:spAutoFit/>
+          </a:bodyPr>
+          <a:lstStyle/>
+          <a:p>
+            <a:pPr algn="ctr"/>
+            <a:r>
+              <a:rPr lang="pt-BR" sz="1200" b="1" dirty="0"/>
+              <a:t>MANUTENÇÃO EM EQUIPAMENTO</a:t>
+            </a:r>
+          </a:p>
+          <a:p>
+            <a:pPr algn="ctr"/>
+            <a:r>
+              <a:rPr lang="pt-BR" sz="1200" b="1" dirty="0"/>
+              <a:t> NÃO LIGUE</a:t>
+            </a:r>
+          </a:p>
+        </p:txBody>
+      </p:sp>
+      <p:sp>
+        <p:nvSpPr>
+          <p:cNvPr id="106" name="Retângulo 105"/>
+          <p:cNvSpPr/>
+          <p:nvPr/>
+        </p:nvSpPr>
+        <p:spPr>
+          <a:xfrm>
+            <a:off x="6315458" y="1900545"/>
+            <a:ext cx="1929580" cy="646331"/>
+          </a:xfrm>
+          <a:prstGeom prst="rect">
+            <a:avLst/>
+          </a:prstGeom>
+        </p:spPr>
+        <p:txBody>
+          <a:bodyPr wrap="square">
+            <a:spAutoFit/>
+          </a:bodyPr>
+          <a:lstStyle/>
+          <a:p>
+            <a:pPr algn="ctr"/>
+            <a:r>
+              <a:rPr lang="pt-BR" sz="1200" b="1" dirty="0"/>
+              <a:t>MANUTENÇÃO EM EQUIPAMENTO</a:t>
+            </a:r>
+          </a:p>
+          <a:p>
+            <a:pPr algn="ctr"/>
+            <a:r>
+              <a:rPr lang="pt-BR" sz="1200" b="1" dirty="0"/>
+              <a:t> NÃO LIGUE</a:t>
+            </a:r>
+          </a:p>
+        </p:txBody>
+      </p:sp>
+      <p:sp>
+        <p:nvSpPr>
+          <p:cNvPr id="107" name="Retângulo 106"/>
+          <p:cNvSpPr/>
+          <p:nvPr/>
+        </p:nvSpPr>
+        <p:spPr>
+          <a:xfrm>
+            <a:off x="703250" y="1876144"/>
+            <a:ext cx="1929580" cy="646331"/>
+          </a:xfrm>
+          <a:prstGeom prst="rect">
+            <a:avLst/>
+          </a:prstGeom>
+        </p:spPr>
+        <p:txBody>
+          <a:bodyPr wrap="square">
+            <a:spAutoFit/>
+          </a:bodyPr>
+          <a:lstStyle/>
+          <a:p>
+            <a:pPr algn="ctr"/>
+            <a:r>
+              <a:rPr lang="pt-BR" sz="1200" b="1" dirty="0"/>
+              <a:t>MANUTENÇÃO EM EQUIPAMENTO</a:t>
+            </a:r>
+          </a:p>
+          <a:p>
+            <a:pPr algn="ctr"/>
+            <a:r>
+              <a:rPr lang="pt-BR" sz="1200" b="1" dirty="0"/>
+              <a:t> NÃO LIGUE</a:t>
+            </a:r>
+          </a:p>
+        </p:txBody>
+      </p:sp>
+      <p:sp>
+        <p:nvSpPr>
+          <p:cNvPr id="108" name="CARD3_NOME"/>
+          <p:cNvSpPr/>
+          <p:nvPr/>
+        </p:nvSpPr>
+        <p:spPr>
+          <a:xfrm>
+            <a:off x="4615336" y="2540195"/>
+            <a:ext cx="1582282" cy="215444"/>
+          </a:xfrm>
+          <a:prstGeom prst="rect">
+            <a:avLst/>
+          </a:prstGeom>
+        </p:spPr>
+        <p:txBody>
+          <a:bodyPr wrap="square">
+            <a:spAutoFit/>
+          </a:bodyPr>
+          <a:lstStyle/>
+          <a:p>
+            <a:r>
+              <a:rPr lang="pt-BR" sz="800" dirty="0"/>
+              <a:t>{{NOME}}</a:t>
+            </a:r>
+            <a:endParaRPr lang="pt-BR" sz="1200" dirty="0"/>
+          </a:p>
+        </p:txBody>
+      </p:sp>
+      <p:sp>
+        <p:nvSpPr>
+          <p:cNvPr id="15" name="CARD4_NOME"/>
+          <p:cNvSpPr/>
+          <p:nvPr/>
+        </p:nvSpPr>
+        <p:spPr>
+          <a:xfrm>
+            <a:off x="6521422" y="2567070"/>
+            <a:ext cx="583814" cy="338554"/>
           </a:xfrm>
           <a:prstGeom prst="rect">
             <a:avLst/>
@@ -5451,26 +5799,98 @@
           <a:lstStyle/>
           <a:p>
             <a:r>
-              <a:rPr lang="pt-BR" sz="800" dirty="0" err="1"/>
-              <a:t>{{TELEFONE}}</a:t>
-            </a:r>
-            <a:r>
               <a:rPr lang="pt-BR" sz="800" dirty="0"/>
-              <a:t/>
-            </a:r>
-          </a:p>
-        </p:txBody>
-      </p:sp>
-      <p:sp>
-        <p:nvSpPr>
-          <p:cNvPr id="10" name="CARD5_NOME"/>
+              <a:t>{{NOME}}</a:t>
+            </a:r>
+            <a:br>
+              <a:rPr lang="pt-BR" sz="800" dirty="0"/>
+            </a:br>
+            <a:endParaRPr lang="pt-BR" sz="800" dirty="0"/>
+          </a:p>
+        </p:txBody>
+      </p:sp>
+      <p:sp>
+        <p:nvSpPr>
+          <p:cNvPr id="16" name="Retângulo 15"/>
           <p:cNvSpPr/>
           <p:nvPr/>
         </p:nvSpPr>
         <p:spPr>
           <a:xfrm>
-            <a:off x="717506" y="5618422"/>
-            <a:ext cx="1898277" cy="276999"/>
+            <a:off x="4514593" y="4919126"/>
+            <a:ext cx="1811006" cy="646331"/>
+          </a:xfrm>
+          <a:prstGeom prst="rect">
+            <a:avLst/>
+          </a:prstGeom>
+        </p:spPr>
+        <p:txBody>
+          <a:bodyPr wrap="square">
+            <a:spAutoFit/>
+          </a:bodyPr>
+          <a:lstStyle/>
+          <a:p>
+            <a:pPr algn="ctr"/>
+            <a:r>
+              <a:rPr lang="pt-BR" sz="1200" b="1" dirty="0"/>
+              <a:t>MANUTENÇÃO EM EQUIPAMENTO</a:t>
+            </a:r>
+          </a:p>
+          <a:p>
+            <a:pPr algn="ctr"/>
+            <a:r>
+              <a:rPr lang="pt-BR" sz="1200" b="1" dirty="0"/>
+              <a:t> NÃO LIGUE</a:t>
+            </a:r>
+          </a:p>
+        </p:txBody>
+      </p:sp>
+      <p:sp>
+        <p:nvSpPr>
+          <p:cNvPr id="109" name="Retângulo 108"/>
+          <p:cNvSpPr/>
+          <p:nvPr/>
+        </p:nvSpPr>
+        <p:spPr>
+          <a:xfrm>
+            <a:off x="6450792" y="4937546"/>
+            <a:ext cx="1811006" cy="646331"/>
+          </a:xfrm>
+          <a:prstGeom prst="rect">
+            <a:avLst/>
+          </a:prstGeom>
+        </p:spPr>
+        <p:txBody>
+          <a:bodyPr wrap="square">
+            <a:spAutoFit/>
+          </a:bodyPr>
+          <a:lstStyle/>
+          <a:p>
+            <a:pPr algn="ctr"/>
+            <a:r>
+              <a:rPr lang="pt-BR" sz="1200" b="1" dirty="0"/>
+              <a:t>MANUTENÇÃO EM EQUIPAMENTO</a:t>
+            </a:r>
+          </a:p>
+          <a:p>
+            <a:pPr algn="ctr"/>
+            <a:r>
+              <a:rPr lang="pt-BR" sz="1200" b="1" dirty="0"/>
+              <a:t> NÃO LIGUE</a:t>
+            </a:r>
+          </a:p>
+        </p:txBody>
+      </p:sp>
+      <p:sp>
+        <p:nvSpPr>
+          <p:cNvPr id="111" name="CARD7_NOME"/>
+          <p:cNvSpPr/>
+          <p:nvPr/>
+        </p:nvSpPr>
+        <p:spPr>
+          <a:xfrm>
+            <a:off x="4623186" y="5562922"/>
+            <a:ext cx="1555041" cy="276999"/>
           </a:xfrm>
           <a:prstGeom prst="rect">
             <a:avLst/>
@@ -5483,7 +5903,7 @@
           <a:lstStyle/>
           <a:p>
             <a:r>
-              <a:rPr lang="pt-BR" sz="800" dirty="0" smtClean="0"/>
+              <a:rPr lang="pt-BR" sz="800" dirty="0"/>
               <a:t>{{NOME}}</a:t>
             </a:r>
             <a:endParaRPr lang="pt-BR" sz="1200" dirty="0"/>
@@ -5492,14 +5912,14 @@
       </p:sp>
       <p:sp>
         <p:nvSpPr>
-          <p:cNvPr id="11" name="CARD5_FUNCAO"/>
+          <p:cNvPr id="112" name="CARD7_FUNCAO"/>
           <p:cNvSpPr/>
           <p:nvPr/>
         </p:nvSpPr>
         <p:spPr>
           <a:xfrm>
-            <a:off x="765228" y="5840035"/>
-            <a:ext cx="1808637" cy="276999"/>
+            <a:off x="4623186" y="5849947"/>
+            <a:ext cx="1509965" cy="276999"/>
           </a:xfrm>
           <a:prstGeom prst="rect">
             <a:avLst/>
@@ -5520,14 +5940,14 @@
       </p:sp>
       <p:sp>
         <p:nvSpPr>
-          <p:cNvPr id="12" name="CARD5_TELEFONE"/>
+          <p:cNvPr id="113" name="CARD7_TELEFONE"/>
           <p:cNvSpPr/>
           <p:nvPr/>
         </p:nvSpPr>
         <p:spPr>
           <a:xfrm>
-            <a:off x="994252" y="6059029"/>
-            <a:ext cx="1381276" cy="276999"/>
+            <a:off x="4623186" y="6124411"/>
+            <a:ext cx="1405321" cy="276999"/>
           </a:xfrm>
           <a:prstGeom prst="rect">
             <a:avLst/>
@@ -5542,579 +5962,6 @@
             <a:r>
               <a:rPr lang="pt-BR" sz="800" dirty="0" err="1"/>
               <a:t>{{TELEFONE}}</a:t>
-            </a:r>
-            <a:r>
-              <a:rPr lang="pt-BR" sz="800" dirty="0"/>
-              <a:t/>
-            </a:r>
-          </a:p>
-        </p:txBody>
-      </p:sp>
-      <p:sp>
-        <p:nvSpPr>
-          <p:cNvPr id="73" name="CARD6_NOME"/>
-          <p:cNvSpPr/>
-          <p:nvPr/>
-        </p:nvSpPr>
-        <p:spPr>
-          <a:xfrm>
-            <a:off x="3035049" y="5624336"/>
-            <a:ext cx="1061957" cy="276999"/>
-          </a:xfrm>
-          <a:prstGeom prst="rect">
-            <a:avLst/>
-          </a:prstGeom>
-        </p:spPr>
-        <p:txBody>
-          <a:bodyPr wrap="none">
-            <a:spAutoFit/>
-          </a:bodyPr>
-          <a:lstStyle/>
-          <a:p>
-            <a:r>
-              <a:rPr lang="pt-BR" sz="800" dirty="0" smtClean="0"/>
-              <a:t>{{NOME}}</a:t>
-            </a:r>
-            <a:endParaRPr lang="pt-BR" sz="1200" dirty="0"/>
-          </a:p>
-        </p:txBody>
-      </p:sp>
-      <p:sp>
-        <p:nvSpPr>
-          <p:cNvPr id="74" name="CARD6_FUNCAO"/>
-          <p:cNvSpPr/>
-          <p:nvPr/>
-        </p:nvSpPr>
-        <p:spPr>
-          <a:xfrm>
-            <a:off x="2672132" y="5825202"/>
-            <a:ext cx="1808637" cy="276999"/>
-          </a:xfrm>
-          <a:prstGeom prst="rect">
-            <a:avLst/>
-          </a:prstGeom>
-        </p:spPr>
-        <p:txBody>
-          <a:bodyPr wrap="none">
-            <a:spAutoFit/>
-          </a:bodyPr>
-          <a:lstStyle/>
-          <a:p>
-            <a:r>
-              <a:rPr lang="pt-BR" sz="750" dirty="0" smtClean="0"/>
-              <a:t>{{FUNCAO}}</a:t>
-            </a:r>
-            <a:endParaRPr lang="pt-BR" sz="1200" dirty="0"/>
-          </a:p>
-        </p:txBody>
-      </p:sp>
-      <p:sp>
-        <p:nvSpPr>
-          <p:cNvPr id="75" name="CARD6_TELEFONE"/>
-          <p:cNvSpPr/>
-          <p:nvPr/>
-        </p:nvSpPr>
-        <p:spPr>
-          <a:xfrm>
-            <a:off x="2859182" y="6027540"/>
-            <a:ext cx="1381276" cy="276999"/>
-          </a:xfrm>
-          <a:prstGeom prst="rect">
-            <a:avLst/>
-          </a:prstGeom>
-        </p:spPr>
-        <p:txBody>
-          <a:bodyPr wrap="none">
-            <a:spAutoFit/>
-          </a:bodyPr>
-          <a:lstStyle/>
-          <a:p>
-            <a:r>
-              <a:rPr lang="pt-BR" sz="800" dirty="0" err="1"/>
-              <a:t>{{TELEFONE}}</a:t>
-            </a:r>
-            <a:r>
-              <a:rPr lang="pt-BR" sz="800" dirty="0"/>
-              <a:t/>
-            </a:r>
-          </a:p>
-        </p:txBody>
-      </p:sp>
-      <p:sp>
-        <p:nvSpPr>
-          <p:cNvPr id="89" name="Retângulo 88"/>
-          <p:cNvSpPr/>
-          <p:nvPr/>
-        </p:nvSpPr>
-        <p:spPr>
-          <a:xfrm>
-            <a:off x="4591842" y="1870562"/>
-            <a:ext cx="1929580" cy="646331"/>
-          </a:xfrm>
-          <a:prstGeom prst="rect">
-            <a:avLst/>
-          </a:prstGeom>
-        </p:spPr>
-        <p:txBody>
-          <a:bodyPr wrap="square">
-            <a:spAutoFit/>
-          </a:bodyPr>
-          <a:lstStyle/>
-          <a:p>
-            <a:pPr algn="ctr"/>
-            <a:r>
-              <a:rPr lang="pt-BR" sz="1200" b="1" dirty="0"/>
-              <a:t>MANUTENÇÃO EM </a:t>
-            </a:r>
-            <a:r>
-              <a:rPr lang="pt-BR" sz="1200" b="1" dirty="0" smtClean="0"/>
-              <a:t>EQUIPAMENTO</a:t>
-            </a:r>
-          </a:p>
-          <a:p>
-            <a:pPr algn="ctr"/>
-            <a:r>
-              <a:rPr lang="pt-BR" sz="1200" b="1" dirty="0" smtClean="0"/>
-              <a:t> </a:t>
-            </a:r>
-            <a:r>
-              <a:rPr lang="pt-BR" sz="1200" b="1" dirty="0"/>
-              <a:t>NÃO </a:t>
-            </a:r>
-            <a:r>
-              <a:rPr lang="pt-BR" sz="1200" b="1" dirty="0" smtClean="0"/>
-              <a:t>LIGUE</a:t>
-            </a:r>
-            <a:endParaRPr lang="pt-BR" sz="1200" b="1" dirty="0"/>
-          </a:p>
-        </p:txBody>
-      </p:sp>
-      <p:sp>
-        <p:nvSpPr>
-          <p:cNvPr id="93" name="Retângulo 92"/>
-          <p:cNvSpPr/>
-          <p:nvPr/>
-        </p:nvSpPr>
-        <p:spPr>
-          <a:xfrm>
-            <a:off x="703250" y="4943364"/>
-            <a:ext cx="1929580" cy="646331"/>
-          </a:xfrm>
-          <a:prstGeom prst="rect">
-            <a:avLst/>
-          </a:prstGeom>
-        </p:spPr>
-        <p:txBody>
-          <a:bodyPr wrap="square">
-            <a:spAutoFit/>
-          </a:bodyPr>
-          <a:lstStyle/>
-          <a:p>
-            <a:pPr algn="ctr"/>
-            <a:r>
-              <a:rPr lang="pt-BR" sz="1200" b="1" dirty="0"/>
-              <a:t>MANUTENÇÃO EM </a:t>
-            </a:r>
-            <a:r>
-              <a:rPr lang="pt-BR" sz="1200" b="1" dirty="0" smtClean="0"/>
-              <a:t>EQUIPAMENTO</a:t>
-            </a:r>
-          </a:p>
-          <a:p>
-            <a:pPr algn="ctr"/>
-            <a:r>
-              <a:rPr lang="pt-BR" sz="1200" b="1" dirty="0" smtClean="0"/>
-              <a:t> </a:t>
-            </a:r>
-            <a:r>
-              <a:rPr lang="pt-BR" sz="1200" b="1" dirty="0"/>
-              <a:t>NÃO </a:t>
-            </a:r>
-            <a:r>
-              <a:rPr lang="pt-BR" sz="1200" b="1" dirty="0" smtClean="0"/>
-              <a:t>LIGUE</a:t>
-            </a:r>
-            <a:endParaRPr lang="pt-BR" sz="1200" b="1" dirty="0"/>
-          </a:p>
-        </p:txBody>
-      </p:sp>
-      <p:sp>
-        <p:nvSpPr>
-          <p:cNvPr id="105" name="Retângulo 104"/>
-          <p:cNvSpPr/>
-          <p:nvPr/>
-        </p:nvSpPr>
-        <p:spPr>
-          <a:xfrm>
-            <a:off x="2696162" y="1880649"/>
-            <a:ext cx="1929580" cy="646331"/>
-          </a:xfrm>
-          <a:prstGeom prst="rect">
-            <a:avLst/>
-          </a:prstGeom>
-        </p:spPr>
-        <p:txBody>
-          <a:bodyPr wrap="square">
-            <a:spAutoFit/>
-          </a:bodyPr>
-          <a:lstStyle/>
-          <a:p>
-            <a:pPr algn="ctr"/>
-            <a:r>
-              <a:rPr lang="pt-BR" sz="1200" b="1" dirty="0"/>
-              <a:t>MANUTENÇÃO EM </a:t>
-            </a:r>
-            <a:r>
-              <a:rPr lang="pt-BR" sz="1200" b="1" dirty="0" smtClean="0"/>
-              <a:t>EQUIPAMENTO</a:t>
-            </a:r>
-          </a:p>
-          <a:p>
-            <a:pPr algn="ctr"/>
-            <a:r>
-              <a:rPr lang="pt-BR" sz="1200" b="1" dirty="0" smtClean="0"/>
-              <a:t> </a:t>
-            </a:r>
-            <a:r>
-              <a:rPr lang="pt-BR" sz="1200" b="1" dirty="0"/>
-              <a:t>NÃO </a:t>
-            </a:r>
-            <a:r>
-              <a:rPr lang="pt-BR" sz="1200" b="1" dirty="0" smtClean="0"/>
-              <a:t>LIGUE</a:t>
-            </a:r>
-            <a:endParaRPr lang="pt-BR" sz="1200" b="1" dirty="0"/>
-          </a:p>
-        </p:txBody>
-      </p:sp>
-      <p:sp>
-        <p:nvSpPr>
-          <p:cNvPr id="106" name="Retângulo 105"/>
-          <p:cNvSpPr/>
-          <p:nvPr/>
-        </p:nvSpPr>
-        <p:spPr>
-          <a:xfrm>
-            <a:off x="6315458" y="1900545"/>
-            <a:ext cx="1929580" cy="646331"/>
-          </a:xfrm>
-          <a:prstGeom prst="rect">
-            <a:avLst/>
-          </a:prstGeom>
-        </p:spPr>
-        <p:txBody>
-          <a:bodyPr wrap="square">
-            <a:spAutoFit/>
-          </a:bodyPr>
-          <a:lstStyle/>
-          <a:p>
-            <a:pPr algn="ctr"/>
-            <a:r>
-              <a:rPr lang="pt-BR" sz="1200" b="1" dirty="0"/>
-              <a:t>MANUTENÇÃO EM </a:t>
-            </a:r>
-            <a:r>
-              <a:rPr lang="pt-BR" sz="1200" b="1" dirty="0" smtClean="0"/>
-              <a:t>EQUIPAMENTO</a:t>
-            </a:r>
-          </a:p>
-          <a:p>
-            <a:pPr algn="ctr"/>
-            <a:r>
-              <a:rPr lang="pt-BR" sz="1200" b="1" dirty="0" smtClean="0"/>
-              <a:t> </a:t>
-            </a:r>
-            <a:r>
-              <a:rPr lang="pt-BR" sz="1200" b="1" dirty="0"/>
-              <a:t>NÃO </a:t>
-            </a:r>
-            <a:r>
-              <a:rPr lang="pt-BR" sz="1200" b="1" dirty="0" smtClean="0"/>
-              <a:t>LIGUE</a:t>
-            </a:r>
-            <a:endParaRPr lang="pt-BR" sz="1200" b="1" dirty="0"/>
-          </a:p>
-        </p:txBody>
-      </p:sp>
-      <p:sp>
-        <p:nvSpPr>
-          <p:cNvPr id="107" name="Retângulo 106"/>
-          <p:cNvSpPr/>
-          <p:nvPr/>
-        </p:nvSpPr>
-        <p:spPr>
-          <a:xfrm>
-            <a:off x="703250" y="1876144"/>
-            <a:ext cx="1929580" cy="646331"/>
-          </a:xfrm>
-          <a:prstGeom prst="rect">
-            <a:avLst/>
-          </a:prstGeom>
-        </p:spPr>
-        <p:txBody>
-          <a:bodyPr wrap="square">
-            <a:spAutoFit/>
-          </a:bodyPr>
-          <a:lstStyle/>
-          <a:p>
-            <a:pPr algn="ctr"/>
-            <a:r>
-              <a:rPr lang="pt-BR" sz="1200" b="1" dirty="0"/>
-              <a:t>MANUTENÇÃO EM </a:t>
-            </a:r>
-            <a:r>
-              <a:rPr lang="pt-BR" sz="1200" b="1" dirty="0" smtClean="0"/>
-              <a:t>EQUIPAMENTO</a:t>
-            </a:r>
-          </a:p>
-          <a:p>
-            <a:pPr algn="ctr"/>
-            <a:r>
-              <a:rPr lang="pt-BR" sz="1200" b="1" dirty="0" smtClean="0"/>
-              <a:t> </a:t>
-            </a:r>
-            <a:r>
-              <a:rPr lang="pt-BR" sz="1200" b="1" dirty="0"/>
-              <a:t>NÃO </a:t>
-            </a:r>
-            <a:r>
-              <a:rPr lang="pt-BR" sz="1200" b="1" dirty="0" smtClean="0"/>
-              <a:t>LIGUE</a:t>
-            </a:r>
-            <a:endParaRPr lang="pt-BR" sz="1200" b="1" dirty="0"/>
-          </a:p>
-        </p:txBody>
-      </p:sp>
-      <p:sp>
-        <p:nvSpPr>
-          <p:cNvPr id="108" name="CARD3_NOME"/>
-          <p:cNvSpPr/>
-          <p:nvPr/>
-        </p:nvSpPr>
-        <p:spPr>
-          <a:xfrm>
-            <a:off x="4642576" y="2540195"/>
-            <a:ext cx="1555041" cy="276999"/>
-          </a:xfrm>
-          <a:prstGeom prst="rect">
-            <a:avLst/>
-          </a:prstGeom>
-        </p:spPr>
-        <p:txBody>
-          <a:bodyPr wrap="none">
-            <a:spAutoFit/>
-          </a:bodyPr>
-          <a:lstStyle/>
-          <a:p>
-            <a:r>
-              <a:rPr lang="pt-BR" sz="800" dirty="0" smtClean="0"/>
-              <a:t>{{NOME}}</a:t>
-            </a:r>
-            <a:endParaRPr lang="pt-BR" sz="1200" dirty="0"/>
-          </a:p>
-        </p:txBody>
-      </p:sp>
-      <p:sp>
-        <p:nvSpPr>
-          <p:cNvPr id="15" name="CARD4_NOME"/>
-          <p:cNvSpPr/>
-          <p:nvPr/>
-        </p:nvSpPr>
-        <p:spPr>
-          <a:xfrm>
-            <a:off x="6521422" y="2567070"/>
-            <a:ext cx="1688604" cy="276999"/>
-          </a:xfrm>
-          <a:prstGeom prst="rect">
-            <a:avLst/>
-          </a:prstGeom>
-        </p:spPr>
-        <p:txBody>
-          <a:bodyPr wrap="none">
-            <a:spAutoFit/>
-          </a:bodyPr>
-          <a:lstStyle/>
-          <a:p>
-            <a:r>
-              <a:rPr lang="pt-BR" sz="800" dirty="0"/>
-              <a:t>{{NOME}}</a:t>
-            </a:r>
-            <a:r>
-              <a:rPr lang="pt-BR" sz="800" dirty="0" smtClean="0"/>
-              <a:t/>
-            </a:r>
-            <a:r>
-              <a:rPr lang="pt-BR" sz="800" dirty="0"/>
-              <a:t/>
-            </a:r>
-          </a:p>
-        </p:txBody>
-      </p:sp>
-      <p:sp>
-        <p:nvSpPr>
-          <p:cNvPr id="16" name="Retângulo 15"/>
-          <p:cNvSpPr/>
-          <p:nvPr/>
-        </p:nvSpPr>
-        <p:spPr>
-          <a:xfrm>
-            <a:off x="4514593" y="4919126"/>
-            <a:ext cx="1811006" cy="646331"/>
-          </a:xfrm>
-          <a:prstGeom prst="rect">
-            <a:avLst/>
-          </a:prstGeom>
-        </p:spPr>
-        <p:txBody>
-          <a:bodyPr wrap="square">
-            <a:spAutoFit/>
-          </a:bodyPr>
-          <a:lstStyle/>
-          <a:p>
-            <a:pPr algn="ctr"/>
-            <a:r>
-              <a:rPr lang="pt-BR" sz="1200" b="1" dirty="0"/>
-              <a:t>MANUTENÇÃO EM EQUIPAMENTO</a:t>
-            </a:r>
-          </a:p>
-          <a:p>
-            <a:pPr algn="ctr"/>
-            <a:r>
-              <a:rPr lang="pt-BR" sz="1200" b="1" dirty="0"/>
-              <a:t> NÃO LIGUE</a:t>
-            </a:r>
-          </a:p>
-        </p:txBody>
-      </p:sp>
-      <p:sp>
-        <p:nvSpPr>
-          <p:cNvPr id="109" name="Retângulo 108"/>
-          <p:cNvSpPr/>
-          <p:nvPr/>
-        </p:nvSpPr>
-        <p:spPr>
-          <a:xfrm>
-            <a:off x="6450792" y="4937546"/>
-            <a:ext cx="1811006" cy="646331"/>
-          </a:xfrm>
-          <a:prstGeom prst="rect">
-            <a:avLst/>
-          </a:prstGeom>
-        </p:spPr>
-        <p:txBody>
-          <a:bodyPr wrap="square">
-            <a:spAutoFit/>
-          </a:bodyPr>
-          <a:lstStyle/>
-          <a:p>
-            <a:pPr algn="ctr"/>
-            <a:r>
-              <a:rPr lang="pt-BR" sz="1200" b="1" dirty="0"/>
-              <a:t>MANUTENÇÃO EM EQUIPAMENTO</a:t>
-            </a:r>
-          </a:p>
-          <a:p>
-            <a:pPr algn="ctr"/>
-            <a:r>
-              <a:rPr lang="pt-BR" sz="1200" b="1" dirty="0"/>
-              <a:t> NÃO LIGUE</a:t>
-            </a:r>
-          </a:p>
-        </p:txBody>
-      </p:sp>
-      <p:sp>
-        <p:nvSpPr>
-          <p:cNvPr id="111" name="CARD7_NOME"/>
-          <p:cNvSpPr/>
-          <p:nvPr/>
-        </p:nvSpPr>
-        <p:spPr>
-          <a:xfrm>
-            <a:off x="4705902" y="5553083"/>
-            <a:ext cx="1555041" cy="276999"/>
-          </a:xfrm>
-          <a:prstGeom prst="rect">
-            <a:avLst/>
-          </a:prstGeom>
-        </p:spPr>
-        <p:txBody>
-          <a:bodyPr wrap="none">
-            <a:spAutoFit/>
-          </a:bodyPr>
-          <a:lstStyle/>
-          <a:p>
-            <a:r>
-              <a:rPr lang="pt-BR" sz="800" dirty="0" smtClean="0"/>
-              <a:t>{{NOME}}</a:t>
-            </a:r>
-            <a:endParaRPr lang="pt-BR" sz="1200" dirty="0"/>
-          </a:p>
-        </p:txBody>
-      </p:sp>
-      <p:sp>
-        <p:nvSpPr>
-          <p:cNvPr id="112" name="CARD7_FUNCAO"/>
-          <p:cNvSpPr/>
-          <p:nvPr/>
-        </p:nvSpPr>
-        <p:spPr>
-          <a:xfrm>
-            <a:off x="4687652" y="5796283"/>
-            <a:ext cx="1509965" cy="276999"/>
-          </a:xfrm>
-          <a:prstGeom prst="rect">
-            <a:avLst/>
-          </a:prstGeom>
-        </p:spPr>
-        <p:txBody>
-          <a:bodyPr wrap="none">
-            <a:spAutoFit/>
-          </a:bodyPr>
-          <a:lstStyle/>
-          <a:p>
-            <a:r>
-              <a:rPr lang="pt-BR" sz="750" dirty="0" smtClean="0"/>
-              <a:t>{{FUNCAO}}</a:t>
-            </a:r>
-            <a:r>
-              <a:rPr lang="pt-BR" sz="750" dirty="0"/>
-              <a:t/>
-            </a:r>
-          </a:p>
-        </p:txBody>
-      </p:sp>
-      <p:sp>
-        <p:nvSpPr>
-          <p:cNvPr id="113" name="CARD7_TELEFONE"/>
-          <p:cNvSpPr/>
-          <p:nvPr/>
-        </p:nvSpPr>
-        <p:spPr>
-          <a:xfrm>
-            <a:off x="4739973" y="6015476"/>
-            <a:ext cx="1405321" cy="276999"/>
-          </a:xfrm>
-          <a:prstGeom prst="rect">
-            <a:avLst/>
-          </a:prstGeom>
-        </p:spPr>
-        <p:txBody>
-          <a:bodyPr wrap="none">
-            <a:spAutoFit/>
-          </a:bodyPr>
-          <a:lstStyle/>
-          <a:p>
-            <a:r>
-              <a:rPr lang="pt-BR" sz="800" dirty="0" err="1"/>
-              <a:t>{{TELEFONE}}</a:t>
-            </a:r>
-            <a:r>
-              <a:rPr lang="pt-BR" sz="800" dirty="0"/>
-              <a:t/>
-            </a:r>
-            <a:r>
-              <a:rPr lang="pt-BR" sz="800" dirty="0" smtClean="0"/>
-              <a:t/>
             </a:r>
             <a:endParaRPr lang="pt-BR" sz="1200" dirty="0"/>
           </a:p>
@@ -6232,7 +6079,7 @@
         </p:blipFill>
         <p:spPr>
           <a:xfrm>
-            <a:off x="1314000" y="3931200"/>
+            <a:off x="1313576" y="3893916"/>
             <a:ext cx="684000" cy="917999"/>
           </a:xfrm>
           <a:prstGeom prst="rect">
@@ -6256,7 +6103,7 @@
         </p:blipFill>
         <p:spPr>
           <a:xfrm>
-            <a:off x="3240000" y="3931200"/>
+            <a:off x="3247535" y="3890402"/>
             <a:ext cx="684000" cy="917999"/>
           </a:xfrm>
           <a:prstGeom prst="rect">
@@ -6280,7 +6127,7 @@
         </p:blipFill>
         <p:spPr>
           <a:xfrm>
-            <a:off x="5162400" y="3931200"/>
+            <a:off x="5162675" y="3887482"/>
             <a:ext cx="684000" cy="917999"/>
           </a:xfrm>
           <a:prstGeom prst="rect">
@@ -6288,6 +6135,140 @@
           </a:prstGeom>
         </p:spPr>
       </p:pic>
+      <p:pic>
+        <p:nvPicPr>
+          <p:cNvPr id="83" name="CARD7_FOTO" descr="image.jpg">
+            <a:extLst>
+              <a:ext uri="{FF2B5EF4-FFF2-40B4-BE49-F238E27FC236}">
+                <a16:creationId xmlns:a16="http://schemas.microsoft.com/office/drawing/2014/main" id="{7C2EDF45-4F5E-402F-92A8-2BCF80D8EBED}"/>
+              </a:ext>
+            </a:extLst>
+          </p:cNvPr>
+          <p:cNvPicPr>
+            <a:picLocks noChangeAspect="1"/>
+          </p:cNvPicPr>
+          <p:nvPr/>
+        </p:nvPicPr>
+        <p:blipFill>
+          <a:blip r:embed="rId5"/>
+          <a:stretch>
+            <a:fillRect/>
+          </a:stretch>
+        </p:blipFill>
+        <p:spPr>
+          <a:xfrm>
+            <a:off x="7051776" y="3902722"/>
+            <a:ext cx="684000" cy="917999"/>
+          </a:xfrm>
+          <a:prstGeom prst="rect">
+            <a:avLst/>
+          </a:prstGeom>
+        </p:spPr>
+      </p:pic>
+      <p:sp>
+        <p:nvSpPr>
+          <p:cNvPr id="87" name="CARD7_NOME">
+            <a:extLst>
+              <a:ext uri="{FF2B5EF4-FFF2-40B4-BE49-F238E27FC236}">
+                <a16:creationId xmlns:a16="http://schemas.microsoft.com/office/drawing/2014/main" id="{C46FDD3C-CA35-457D-853F-EDA346493698}"/>
+              </a:ext>
+            </a:extLst>
+          </p:cNvPr>
+          <p:cNvSpPr/>
+          <p:nvPr/>
+        </p:nvSpPr>
+        <p:spPr>
+          <a:xfrm>
+            <a:off x="6506631" y="5592486"/>
+            <a:ext cx="1555041" cy="276999"/>
+          </a:xfrm>
+          <a:prstGeom prst="rect">
+            <a:avLst/>
+          </a:prstGeom>
+        </p:spPr>
+        <p:txBody>
+          <a:bodyPr wrap="none">
+            <a:spAutoFit/>
+          </a:bodyPr>
+          <a:lstStyle/>
+          <a:p>
+            <a:r>
+              <a:rPr lang="pt-BR" sz="800" dirty="0"/>
+              <a:t>{{NOME}}</a:t>
+            </a:r>
+            <a:endParaRPr lang="pt-BR" sz="1200" dirty="0"/>
+          </a:p>
+        </p:txBody>
+      </p:sp>
+      <p:sp>
+        <p:nvSpPr>
+          <p:cNvPr id="88" name="CARD7_FUNCAO">
+            <a:extLst>
+              <a:ext uri="{FF2B5EF4-FFF2-40B4-BE49-F238E27FC236}">
+                <a16:creationId xmlns:a16="http://schemas.microsoft.com/office/drawing/2014/main" id="{6E19A8D6-403C-475C-85F4-0AF859622ECB}"/>
+              </a:ext>
+            </a:extLst>
+          </p:cNvPr>
+          <p:cNvSpPr/>
+          <p:nvPr/>
+        </p:nvSpPr>
+        <p:spPr>
+          <a:xfrm>
+            <a:off x="6506631" y="5879511"/>
+            <a:ext cx="1509965" cy="276999"/>
+          </a:xfrm>
+          <a:prstGeom prst="rect">
+            <a:avLst/>
+          </a:prstGeom>
+        </p:spPr>
+        <p:txBody>
+          <a:bodyPr wrap="none">
+            <a:spAutoFit/>
+          </a:bodyPr>
+          <a:lstStyle/>
+          <a:p>
+            <a:r>
+              <a:rPr lang="pt-BR" sz="750" dirty="0"/>
+              <a:t>{{FUNCAO}}</a:t>
+            </a:r>
+          </a:p>
+        </p:txBody>
+      </p:sp>
+      <p:sp>
+        <p:nvSpPr>
+          <p:cNvPr id="104" name="CARD7_TELEFONE">
+            <a:extLst>
+              <a:ext uri="{FF2B5EF4-FFF2-40B4-BE49-F238E27FC236}">
+                <a16:creationId xmlns:a16="http://schemas.microsoft.com/office/drawing/2014/main" id="{5B59F489-94E9-456F-9A37-87E8E41C15AE}"/>
+              </a:ext>
+            </a:extLst>
+          </p:cNvPr>
+          <p:cNvSpPr/>
+          <p:nvPr/>
+        </p:nvSpPr>
+        <p:spPr>
+          <a:xfrm>
+            <a:off x="6506631" y="6153975"/>
+            <a:ext cx="1405321" cy="276999"/>
+          </a:xfrm>
+          <a:prstGeom prst="rect">
+            <a:avLst/>
+          </a:prstGeom>
+        </p:spPr>
+        <p:txBody>
+          <a:bodyPr wrap="none">
+            <a:spAutoFit/>
+          </a:bodyPr>
+          <a:lstStyle/>
+          <a:p>
+            <a:r>
+              <a:rPr lang="pt-BR" sz="800" dirty="0" err="1"/>
+              <a:t>{{TELEFONE}}</a:t>
+            </a:r>
+            <a:endParaRPr lang="pt-BR" sz="1200" dirty="0"/>
+          </a:p>
+        </p:txBody>
+      </p:sp>
     </p:spTree>
     <p:extLst>
       <p:ext uri="{BB962C8B-B14F-4D97-AF65-F5344CB8AC3E}">
@@ -6298,13 +6279,6 @@
   <p:clrMapOvr>
     <a:masterClrMapping/>
   </p:clrMapOvr>
-  <p:timing>
-    <p:tnLst>
-      <p:par>
-        <p:cTn id="1" dur="indefinite" restart="never" nodeType="tmRoot"/>
-      </p:par>
-    </p:tnLst>
-  </p:timing>
 </p:sld>
 </file>
 

</xml_diff>

<commit_message>
feat: revisao da emissao editavel, quebra de linha/clip e ALTEC-PEQUENO 8 cartoes
- EmissionReviewDialog: editar nome/funcao/telefone/foto por emissao (copias
  transitarias, nada grava no banco) + Voltar e Editar no preview
- word_wrap + auto-shrink vertical (margens verticais zeradas p/ caber 2 linhas)
- LOTOTO text_fit=clip: corta texto no limite do campo, sem quebra/encolher
- ALTEC-PEQUENO: slot 8 renomeado CARD8_* (antes duplicava o 7o), 8 zonas,
  CARD3_FUNCAO renomeado, prep reproduz o 8o cartao e a foto T=10.8
- testes: 8 funcionarios, wrap/clip, edicao por emissao; previews regenerados
- docs: PPTX_TEMPLATES (text_fit + revisao), ROADMAP 1.3.0, CHANGELOG 1.3.0
</commit_message>
<xml_diff>
--- a/templates/cards/pptx/ALTEC_PEQUENO.pptx
+++ b/templates/cards/pptx/ALTEC_PEQUENO.pptx
@@ -5199,7 +5199,7 @@
       </p:sp>
       <p:sp>
         <p:nvSpPr>
-          <p:cNvPr id="91" name="CARD3_NOME"/>
+          <p:cNvPr id="91" name="CARD3_FUNCAO"/>
           <p:cNvSpPr/>
           <p:nvPr/>
         </p:nvSpPr>
@@ -5207,34 +5207,6 @@
           <a:xfrm>
             <a:off x="4615336" y="2731487"/>
             <a:ext cx="671979" cy="215444"/>
-          </a:xfrm>
-          <a:prstGeom prst="rect">
-            <a:avLst/>
-          </a:prstGeom>
-        </p:spPr>
-        <p:txBody>
-          <a:bodyPr wrap="none">
-            <a:spAutoFit/>
-          </a:bodyPr>
-          <a:lstStyle/>
-          <a:p>
-            <a:r>
-              <a:rPr lang="pt-BR" sz="800" dirty="0"/>
-              <a:t>{{FUNCAO}}</a:t>
-            </a:r>
-          </a:p>
-        </p:txBody>
-      </p:sp>
-      <p:sp>
-        <p:nvSpPr>
-          <p:cNvPr id="92" name="CARD2_FUNCAO"/>
-          <p:cNvSpPr/>
-          <p:nvPr/>
-        </p:nvSpPr>
-        <p:spPr>
-          <a:xfrm>
-            <a:off x="2723405" y="2795580"/>
-            <a:ext cx="1797027" cy="207749"/>
           </a:xfrm>
           <a:prstGeom prst="rect">
             <a:avLst/>
@@ -5247,23 +5219,22 @@
           <a:lstStyle/>
           <a:p>
             <a:r>
-              <a:rPr lang="pt-BR" sz="750" dirty="0"/>
+              <a:rPr lang="pt-BR" sz="800" dirty="0"/>
               <a:t>{{FUNCAO}}</a:t>
             </a:r>
-            <a:endParaRPr lang="pt-BR" sz="1200" dirty="0"/>
-          </a:p>
-        </p:txBody>
-      </p:sp>
-      <p:sp>
-        <p:nvSpPr>
-          <p:cNvPr id="6" name="CARD1_TELEFONE"/>
+          </a:p>
+        </p:txBody>
+      </p:sp>
+      <p:sp>
+        <p:nvSpPr>
+          <p:cNvPr id="92" name="CARD2_FUNCAO"/>
           <p:cNvSpPr/>
           <p:nvPr/>
         </p:nvSpPr>
         <p:spPr>
           <a:xfrm>
-            <a:off x="813116" y="3005085"/>
-            <a:ext cx="1566576" cy="215444"/>
+            <a:off x="2723405" y="2795580"/>
+            <a:ext cx="1797027" cy="207749"/>
           </a:xfrm>
           <a:prstGeom prst="rect">
             <a:avLst/>
@@ -5276,8 +5247,8 @@
           <a:lstStyle/>
           <a:p>
             <a:r>
-              <a:rPr lang="pt-BR" sz="800" dirty="0" err="1"/>
-              <a:t>{{TELEFONE}}</a:t>
+              <a:rPr lang="pt-BR" sz="750" dirty="0"/>
+              <a:t>{{FUNCAO}}</a:t>
             </a:r>
             <a:endParaRPr lang="pt-BR" sz="1200" dirty="0"/>
           </a:p>
@@ -5285,14 +5256,14 @@
       </p:sp>
       <p:sp>
         <p:nvSpPr>
-          <p:cNvPr id="102" name="CARD2_TELEFONE"/>
+          <p:cNvPr id="6" name="CARD1_TELEFONE"/>
           <p:cNvSpPr/>
           <p:nvPr/>
         </p:nvSpPr>
         <p:spPr>
           <a:xfrm>
-            <a:off x="2723405" y="3003110"/>
-            <a:ext cx="1518433" cy="215444"/>
+            <a:off x="813116" y="3005085"/>
+            <a:ext cx="1566576" cy="215444"/>
           </a:xfrm>
           <a:prstGeom prst="rect">
             <a:avLst/>
@@ -5314,71 +5285,14 @@
       </p:sp>
       <p:sp>
         <p:nvSpPr>
-          <p:cNvPr id="103" name="CARD3_TELEFONE"/>
+          <p:cNvPr id="102" name="CARD2_TELEFONE"/>
           <p:cNvSpPr/>
           <p:nvPr/>
         </p:nvSpPr>
         <p:spPr>
           <a:xfrm>
-            <a:off x="4615336" y="2949544"/>
-            <a:ext cx="1405321" cy="276999"/>
-          </a:xfrm>
-          <a:prstGeom prst="rect">
-            <a:avLst/>
-          </a:prstGeom>
-        </p:spPr>
-        <p:txBody>
-          <a:bodyPr wrap="none">
-            <a:spAutoFit/>
-          </a:bodyPr>
-          <a:lstStyle/>
-          <a:p>
-            <a:r>
-              <a:rPr lang="pt-BR" sz="800" dirty="0" err="1"/>
-              <a:t>{{TELEFONE}}</a:t>
-            </a:r>
-            <a:endParaRPr lang="pt-BR" sz="1200" dirty="0"/>
-          </a:p>
-        </p:txBody>
-      </p:sp>
-      <p:sp>
-        <p:nvSpPr>
-          <p:cNvPr id="8" name="CARD4_FUNCAO"/>
-          <p:cNvSpPr/>
-          <p:nvPr/>
-        </p:nvSpPr>
-        <p:spPr>
-          <a:xfrm>
-            <a:off x="6466476" y="2803299"/>
-            <a:ext cx="1797736" cy="276999"/>
-          </a:xfrm>
-          <a:prstGeom prst="rect">
-            <a:avLst/>
-          </a:prstGeom>
-        </p:spPr>
-        <p:txBody>
-          <a:bodyPr wrap="none">
-            <a:spAutoFit/>
-          </a:bodyPr>
-          <a:lstStyle/>
-          <a:p>
-            <a:r>
-              <a:rPr lang="pt-BR" sz="750" dirty="0"/>
-              <a:t>{{FUNCAO}}</a:t>
-            </a:r>
-          </a:p>
-        </p:txBody>
-      </p:sp>
-      <p:sp>
-        <p:nvSpPr>
-          <p:cNvPr id="9" name="CARD4_TELEFONE"/>
-          <p:cNvSpPr/>
-          <p:nvPr/>
-        </p:nvSpPr>
-        <p:spPr>
-          <a:xfrm>
-            <a:off x="6521422" y="3046102"/>
-            <a:ext cx="1570206" cy="215444"/>
+            <a:off x="2723405" y="3003110"/>
+            <a:ext cx="1518433" cy="215444"/>
           </a:xfrm>
           <a:prstGeom prst="rect">
             <a:avLst/>
@@ -5394,190 +5308,20 @@
               <a:rPr lang="pt-BR" sz="800" dirty="0" err="1"/>
               <a:t>{{TELEFONE}}</a:t>
             </a:r>
-          </a:p>
-        </p:txBody>
-      </p:sp>
-      <p:sp>
-        <p:nvSpPr>
-          <p:cNvPr id="10" name="CARD5_NOME"/>
+            <a:endParaRPr lang="pt-BR" sz="1200" dirty="0"/>
+          </a:p>
+        </p:txBody>
+      </p:sp>
+      <p:sp>
+        <p:nvSpPr>
+          <p:cNvPr id="103" name="CARD3_TELEFONE"/>
           <p:cNvSpPr/>
           <p:nvPr/>
         </p:nvSpPr>
         <p:spPr>
           <a:xfrm>
-            <a:off x="717506" y="5618422"/>
-            <a:ext cx="1898277" cy="276999"/>
-          </a:xfrm>
-          <a:prstGeom prst="rect">
-            <a:avLst/>
-          </a:prstGeom>
-        </p:spPr>
-        <p:txBody>
-          <a:bodyPr wrap="none">
-            <a:spAutoFit/>
-          </a:bodyPr>
-          <a:lstStyle/>
-          <a:p>
-            <a:r>
-              <a:rPr lang="pt-BR" sz="800" dirty="0"/>
-              <a:t>{{NOME}}</a:t>
-            </a:r>
-            <a:endParaRPr lang="pt-BR" sz="1200" dirty="0"/>
-          </a:p>
-        </p:txBody>
-      </p:sp>
-      <p:sp>
-        <p:nvSpPr>
-          <p:cNvPr id="11" name="CARD5_FUNCAO"/>
-          <p:cNvSpPr/>
-          <p:nvPr/>
-        </p:nvSpPr>
-        <p:spPr>
-          <a:xfrm>
-            <a:off x="794878" y="5904967"/>
-            <a:ext cx="1808637" cy="276999"/>
-          </a:xfrm>
-          <a:prstGeom prst="rect">
-            <a:avLst/>
-          </a:prstGeom>
-        </p:spPr>
-        <p:txBody>
-          <a:bodyPr wrap="none">
-            <a:spAutoFit/>
-          </a:bodyPr>
-          <a:lstStyle/>
-          <a:p>
-            <a:r>
-              <a:rPr lang="pt-BR" sz="750" dirty="0"/>
-              <a:t>{{FUNCAO}}</a:t>
-            </a:r>
-          </a:p>
-        </p:txBody>
-      </p:sp>
-      <p:sp>
-        <p:nvSpPr>
-          <p:cNvPr id="12" name="CARD5_TELEFONE"/>
-          <p:cNvSpPr/>
-          <p:nvPr/>
-        </p:nvSpPr>
-        <p:spPr>
-          <a:xfrm>
-            <a:off x="774546" y="6126033"/>
-            <a:ext cx="1381276" cy="276999"/>
-          </a:xfrm>
-          <a:prstGeom prst="rect">
-            <a:avLst/>
-          </a:prstGeom>
-        </p:spPr>
-        <p:txBody>
-          <a:bodyPr wrap="none">
-            <a:spAutoFit/>
-          </a:bodyPr>
-          <a:lstStyle/>
-          <a:p>
-            <a:r>
-              <a:rPr lang="pt-BR" sz="800" dirty="0" err="1"/>
-              <a:t>{{TELEFONE}}</a:t>
-            </a:r>
-          </a:p>
-        </p:txBody>
-      </p:sp>
-      <p:sp>
-        <p:nvSpPr>
-          <p:cNvPr id="73" name="CARD6_NOME"/>
-          <p:cNvSpPr/>
-          <p:nvPr/>
-        </p:nvSpPr>
-        <p:spPr>
-          <a:xfrm>
-            <a:off x="2709021" y="5600445"/>
-            <a:ext cx="1061957" cy="276999"/>
-          </a:xfrm>
-          <a:prstGeom prst="rect">
-            <a:avLst/>
-          </a:prstGeom>
-        </p:spPr>
-        <p:txBody>
-          <a:bodyPr wrap="none">
-            <a:spAutoFit/>
-          </a:bodyPr>
-          <a:lstStyle/>
-          <a:p>
-            <a:r>
-              <a:rPr lang="pt-BR" sz="800" dirty="0"/>
-              <a:t>{{NOME}}</a:t>
-            </a:r>
-            <a:endParaRPr lang="pt-BR" sz="1200" dirty="0"/>
-          </a:p>
-        </p:txBody>
-      </p:sp>
-      <p:sp>
-        <p:nvSpPr>
-          <p:cNvPr id="74" name="CARD6_FUNCAO"/>
-          <p:cNvSpPr/>
-          <p:nvPr/>
-        </p:nvSpPr>
-        <p:spPr>
-          <a:xfrm>
-            <a:off x="2715116" y="5876976"/>
-            <a:ext cx="1808637" cy="276999"/>
-          </a:xfrm>
-          <a:prstGeom prst="rect">
-            <a:avLst/>
-          </a:prstGeom>
-        </p:spPr>
-        <p:txBody>
-          <a:bodyPr wrap="none">
-            <a:spAutoFit/>
-          </a:bodyPr>
-          <a:lstStyle/>
-          <a:p>
-            <a:r>
-              <a:rPr lang="pt-BR" sz="750" dirty="0"/>
-              <a:t>{{FUNCAO}}</a:t>
-            </a:r>
-            <a:endParaRPr lang="pt-BR" sz="1200" dirty="0"/>
-          </a:p>
-        </p:txBody>
-      </p:sp>
-      <p:sp>
-        <p:nvSpPr>
-          <p:cNvPr id="75" name="CARD6_TELEFONE"/>
-          <p:cNvSpPr/>
-          <p:nvPr/>
-        </p:nvSpPr>
-        <p:spPr>
-          <a:xfrm>
-            <a:off x="2716556" y="6116148"/>
-            <a:ext cx="1381276" cy="276999"/>
-          </a:xfrm>
-          <a:prstGeom prst="rect">
-            <a:avLst/>
-          </a:prstGeom>
-        </p:spPr>
-        <p:txBody>
-          <a:bodyPr wrap="none">
-            <a:spAutoFit/>
-          </a:bodyPr>
-          <a:lstStyle/>
-          <a:p>
-            <a:r>
-              <a:rPr lang="pt-BR" sz="800" dirty="0" err="1"/>
-              <a:t>{{TELEFONE}}</a:t>
-            </a:r>
-          </a:p>
-        </p:txBody>
-      </p:sp>
-      <p:sp>
-        <p:nvSpPr>
-          <p:cNvPr id="89" name="Retângulo 88"/>
-          <p:cNvSpPr/>
-          <p:nvPr/>
-        </p:nvSpPr>
-        <p:spPr>
-          <a:xfrm>
-            <a:off x="4591842" y="1870562"/>
-            <a:ext cx="1929580" cy="646331"/>
+            <a:off x="4615336" y="2949544"/>
+            <a:ext cx="1405321" cy="276999"/>
           </a:xfrm>
           <a:prstGeom prst="rect">
             <a:avLst/>
@@ -5589,31 +5333,24 @@
           </a:bodyPr>
           <a:lstStyle/>
           <a:p>
-            <a:pPr algn="ctr"/>
-            <a:r>
-              <a:rPr lang="pt-BR" sz="1200" b="1" dirty="0"/>
-              <a:t>MANUTENÇÃO EM EQUIPAMENTO</a:t>
-            </a:r>
-          </a:p>
-          <a:p>
-            <a:pPr algn="ctr"/>
-            <a:r>
-              <a:rPr lang="pt-BR" sz="1200" b="1" dirty="0"/>
-              <a:t> NÃO LIGUE</a:t>
-            </a:r>
-          </a:p>
-        </p:txBody>
-      </p:sp>
-      <p:sp>
-        <p:nvSpPr>
-          <p:cNvPr id="93" name="Retângulo 92"/>
+            <a:r>
+              <a:rPr lang="pt-BR" sz="800" dirty="0" err="1"/>
+              <a:t>{{TELEFONE}}</a:t>
+            </a:r>
+            <a:endParaRPr lang="pt-BR" sz="1200" dirty="0"/>
+          </a:p>
+        </p:txBody>
+      </p:sp>
+      <p:sp>
+        <p:nvSpPr>
+          <p:cNvPr id="8" name="CARD4_FUNCAO"/>
           <p:cNvSpPr/>
           <p:nvPr/>
         </p:nvSpPr>
         <p:spPr>
           <a:xfrm>
-            <a:off x="703250" y="4943364"/>
-            <a:ext cx="1929580" cy="646331"/>
+            <a:off x="6466476" y="2803299"/>
+            <a:ext cx="1797736" cy="276999"/>
           </a:xfrm>
           <a:prstGeom prst="rect">
             <a:avLst/>
@@ -5625,31 +5362,23 @@
           </a:bodyPr>
           <a:lstStyle/>
           <a:p>
-            <a:pPr algn="ctr"/>
-            <a:r>
-              <a:rPr lang="pt-BR" sz="1200" b="1" dirty="0"/>
-              <a:t>MANUTENÇÃO EM EQUIPAMENTO</a:t>
-            </a:r>
-          </a:p>
-          <a:p>
-            <a:pPr algn="ctr"/>
-            <a:r>
-              <a:rPr lang="pt-BR" sz="1200" b="1" dirty="0"/>
-              <a:t> NÃO LIGUE</a:t>
-            </a:r>
-          </a:p>
-        </p:txBody>
-      </p:sp>
-      <p:sp>
-        <p:nvSpPr>
-          <p:cNvPr id="105" name="Retângulo 104"/>
+            <a:r>
+              <a:rPr lang="pt-BR" sz="750" dirty="0"/>
+              <a:t>{{FUNCAO}}</a:t>
+            </a:r>
+          </a:p>
+        </p:txBody>
+      </p:sp>
+      <p:sp>
+        <p:nvSpPr>
+          <p:cNvPr id="9" name="CARD4_TELEFONE"/>
           <p:cNvSpPr/>
           <p:nvPr/>
         </p:nvSpPr>
         <p:spPr>
           <a:xfrm>
-            <a:off x="2696162" y="1880649"/>
-            <a:ext cx="1929580" cy="646331"/>
+            <a:off x="6521422" y="3046102"/>
+            <a:ext cx="1570206" cy="215444"/>
           </a:xfrm>
           <a:prstGeom prst="rect">
             <a:avLst/>
@@ -5661,31 +5390,23 @@
           </a:bodyPr>
           <a:lstStyle/>
           <a:p>
-            <a:pPr algn="ctr"/>
-            <a:r>
-              <a:rPr lang="pt-BR" sz="1200" b="1" dirty="0"/>
-              <a:t>MANUTENÇÃO EM EQUIPAMENTO</a:t>
-            </a:r>
-          </a:p>
-          <a:p>
-            <a:pPr algn="ctr"/>
-            <a:r>
-              <a:rPr lang="pt-BR" sz="1200" b="1" dirty="0"/>
-              <a:t> NÃO LIGUE</a:t>
-            </a:r>
-          </a:p>
-        </p:txBody>
-      </p:sp>
-      <p:sp>
-        <p:nvSpPr>
-          <p:cNvPr id="106" name="Retângulo 105"/>
+            <a:r>
+              <a:rPr lang="pt-BR" sz="800" dirty="0" err="1"/>
+              <a:t>{{TELEFONE}}</a:t>
+            </a:r>
+          </a:p>
+        </p:txBody>
+      </p:sp>
+      <p:sp>
+        <p:nvSpPr>
+          <p:cNvPr id="10" name="CARD5_NOME"/>
           <p:cNvSpPr/>
           <p:nvPr/>
         </p:nvSpPr>
         <p:spPr>
           <a:xfrm>
-            <a:off x="6315458" y="1900545"/>
-            <a:ext cx="1929580" cy="646331"/>
+            <a:off x="717506" y="5618422"/>
+            <a:ext cx="1898277" cy="276999"/>
           </a:xfrm>
           <a:prstGeom prst="rect">
             <a:avLst/>
@@ -5697,31 +5418,24 @@
           </a:bodyPr>
           <a:lstStyle/>
           <a:p>
-            <a:pPr algn="ctr"/>
-            <a:r>
-              <a:rPr lang="pt-BR" sz="1200" b="1" dirty="0"/>
-              <a:t>MANUTENÇÃO EM EQUIPAMENTO</a:t>
-            </a:r>
-          </a:p>
-          <a:p>
-            <a:pPr algn="ctr"/>
-            <a:r>
-              <a:rPr lang="pt-BR" sz="1200" b="1" dirty="0"/>
-              <a:t> NÃO LIGUE</a:t>
-            </a:r>
-          </a:p>
-        </p:txBody>
-      </p:sp>
-      <p:sp>
-        <p:nvSpPr>
-          <p:cNvPr id="107" name="Retângulo 106"/>
+            <a:r>
+              <a:rPr lang="pt-BR" sz="800" dirty="0"/>
+              <a:t>{{NOME}}</a:t>
+            </a:r>
+            <a:endParaRPr lang="pt-BR" sz="1200" dirty="0"/>
+          </a:p>
+        </p:txBody>
+      </p:sp>
+      <p:sp>
+        <p:nvSpPr>
+          <p:cNvPr id="11" name="CARD5_FUNCAO"/>
           <p:cNvSpPr/>
           <p:nvPr/>
         </p:nvSpPr>
         <p:spPr>
           <a:xfrm>
-            <a:off x="703250" y="1876144"/>
-            <a:ext cx="1929580" cy="646331"/>
+            <a:off x="794878" y="5904967"/>
+            <a:ext cx="1808637" cy="276999"/>
           </a:xfrm>
           <a:prstGeom prst="rect">
             <a:avLst/>
@@ -5733,31 +5447,23 @@
           </a:bodyPr>
           <a:lstStyle/>
           <a:p>
-            <a:pPr algn="ctr"/>
-            <a:r>
-              <a:rPr lang="pt-BR" sz="1200" b="1" dirty="0"/>
-              <a:t>MANUTENÇÃO EM EQUIPAMENTO</a:t>
-            </a:r>
-          </a:p>
-          <a:p>
-            <a:pPr algn="ctr"/>
-            <a:r>
-              <a:rPr lang="pt-BR" sz="1200" b="1" dirty="0"/>
-              <a:t> NÃO LIGUE</a:t>
-            </a:r>
-          </a:p>
-        </p:txBody>
-      </p:sp>
-      <p:sp>
-        <p:nvSpPr>
-          <p:cNvPr id="108" name="CARD3_NOME"/>
+            <a:r>
+              <a:rPr lang="pt-BR" sz="750" dirty="0"/>
+              <a:t>{{FUNCAO}}</a:t>
+            </a:r>
+          </a:p>
+        </p:txBody>
+      </p:sp>
+      <p:sp>
+        <p:nvSpPr>
+          <p:cNvPr id="12" name="CARD5_TELEFONE"/>
           <p:cNvSpPr/>
           <p:nvPr/>
         </p:nvSpPr>
         <p:spPr>
           <a:xfrm>
-            <a:off x="4615336" y="2540195"/>
-            <a:ext cx="1582282" cy="215444"/>
+            <a:off x="774546" y="6126033"/>
+            <a:ext cx="1381276" cy="276999"/>
           </a:xfrm>
           <a:prstGeom prst="rect">
             <a:avLst/>
@@ -5770,6 +5476,34 @@
           <a:lstStyle/>
           <a:p>
             <a:r>
+              <a:rPr lang="pt-BR" sz="800" dirty="0" err="1"/>
+              <a:t>{{TELEFONE}}</a:t>
+            </a:r>
+          </a:p>
+        </p:txBody>
+      </p:sp>
+      <p:sp>
+        <p:nvSpPr>
+          <p:cNvPr id="73" name="CARD6_NOME"/>
+          <p:cNvSpPr/>
+          <p:nvPr/>
+        </p:nvSpPr>
+        <p:spPr>
+          <a:xfrm>
+            <a:off x="2709021" y="5600445"/>
+            <a:ext cx="1061957" cy="276999"/>
+          </a:xfrm>
+          <a:prstGeom prst="rect">
+            <a:avLst/>
+          </a:prstGeom>
+        </p:spPr>
+        <p:txBody>
+          <a:bodyPr wrap="square">
+            <a:spAutoFit/>
+          </a:bodyPr>
+          <a:lstStyle/>
+          <a:p>
+            <a:r>
               <a:rPr lang="pt-BR" sz="800" dirty="0"/>
               <a:t>{{NOME}}</a:t>
             </a:r>
@@ -5779,6 +5513,272 @@
       </p:sp>
       <p:sp>
         <p:nvSpPr>
+          <p:cNvPr id="74" name="CARD6_FUNCAO"/>
+          <p:cNvSpPr/>
+          <p:nvPr/>
+        </p:nvSpPr>
+        <p:spPr>
+          <a:xfrm>
+            <a:off x="2715116" y="5876976"/>
+            <a:ext cx="1808637" cy="276999"/>
+          </a:xfrm>
+          <a:prstGeom prst="rect">
+            <a:avLst/>
+          </a:prstGeom>
+        </p:spPr>
+        <p:txBody>
+          <a:bodyPr wrap="square">
+            <a:spAutoFit/>
+          </a:bodyPr>
+          <a:lstStyle/>
+          <a:p>
+            <a:r>
+              <a:rPr lang="pt-BR" sz="750" dirty="0"/>
+              <a:t>{{FUNCAO}}</a:t>
+            </a:r>
+            <a:endParaRPr lang="pt-BR" sz="1200" dirty="0"/>
+          </a:p>
+        </p:txBody>
+      </p:sp>
+      <p:sp>
+        <p:nvSpPr>
+          <p:cNvPr id="75" name="CARD6_TELEFONE"/>
+          <p:cNvSpPr/>
+          <p:nvPr/>
+        </p:nvSpPr>
+        <p:spPr>
+          <a:xfrm>
+            <a:off x="2716556" y="6116148"/>
+            <a:ext cx="1381276" cy="276999"/>
+          </a:xfrm>
+          <a:prstGeom prst="rect">
+            <a:avLst/>
+          </a:prstGeom>
+        </p:spPr>
+        <p:txBody>
+          <a:bodyPr wrap="square">
+            <a:spAutoFit/>
+          </a:bodyPr>
+          <a:lstStyle/>
+          <a:p>
+            <a:r>
+              <a:rPr lang="pt-BR" sz="800" dirty="0" err="1"/>
+              <a:t>{{TELEFONE}}</a:t>
+            </a:r>
+          </a:p>
+        </p:txBody>
+      </p:sp>
+      <p:sp>
+        <p:nvSpPr>
+          <p:cNvPr id="89" name="Retângulo 88"/>
+          <p:cNvSpPr/>
+          <p:nvPr/>
+        </p:nvSpPr>
+        <p:spPr>
+          <a:xfrm>
+            <a:off x="4591842" y="1870562"/>
+            <a:ext cx="1929580" cy="646331"/>
+          </a:xfrm>
+          <a:prstGeom prst="rect">
+            <a:avLst/>
+          </a:prstGeom>
+        </p:spPr>
+        <p:txBody>
+          <a:bodyPr wrap="square">
+            <a:spAutoFit/>
+          </a:bodyPr>
+          <a:lstStyle/>
+          <a:p>
+            <a:pPr algn="ctr"/>
+            <a:r>
+              <a:rPr lang="pt-BR" sz="1200" b="1" dirty="0"/>
+              <a:t>MANUTENÇÃO EM EQUIPAMENTO</a:t>
+            </a:r>
+          </a:p>
+          <a:p>
+            <a:pPr algn="ctr"/>
+            <a:r>
+              <a:rPr lang="pt-BR" sz="1200" b="1" dirty="0"/>
+              <a:t> NÃO LIGUE</a:t>
+            </a:r>
+          </a:p>
+        </p:txBody>
+      </p:sp>
+      <p:sp>
+        <p:nvSpPr>
+          <p:cNvPr id="93" name="Retângulo 92"/>
+          <p:cNvSpPr/>
+          <p:nvPr/>
+        </p:nvSpPr>
+        <p:spPr>
+          <a:xfrm>
+            <a:off x="703250" y="4943364"/>
+            <a:ext cx="1929580" cy="646331"/>
+          </a:xfrm>
+          <a:prstGeom prst="rect">
+            <a:avLst/>
+          </a:prstGeom>
+        </p:spPr>
+        <p:txBody>
+          <a:bodyPr wrap="square">
+            <a:spAutoFit/>
+          </a:bodyPr>
+          <a:lstStyle/>
+          <a:p>
+            <a:pPr algn="ctr"/>
+            <a:r>
+              <a:rPr lang="pt-BR" sz="1200" b="1" dirty="0"/>
+              <a:t>MANUTENÇÃO EM EQUIPAMENTO</a:t>
+            </a:r>
+          </a:p>
+          <a:p>
+            <a:pPr algn="ctr"/>
+            <a:r>
+              <a:rPr lang="pt-BR" sz="1200" b="1" dirty="0"/>
+              <a:t> NÃO LIGUE</a:t>
+            </a:r>
+          </a:p>
+        </p:txBody>
+      </p:sp>
+      <p:sp>
+        <p:nvSpPr>
+          <p:cNvPr id="105" name="Retângulo 104"/>
+          <p:cNvSpPr/>
+          <p:nvPr/>
+        </p:nvSpPr>
+        <p:spPr>
+          <a:xfrm>
+            <a:off x="2696162" y="1880649"/>
+            <a:ext cx="1929580" cy="646331"/>
+          </a:xfrm>
+          <a:prstGeom prst="rect">
+            <a:avLst/>
+          </a:prstGeom>
+        </p:spPr>
+        <p:txBody>
+          <a:bodyPr wrap="square">
+            <a:spAutoFit/>
+          </a:bodyPr>
+          <a:lstStyle/>
+          <a:p>
+            <a:pPr algn="ctr"/>
+            <a:r>
+              <a:rPr lang="pt-BR" sz="1200" b="1" dirty="0"/>
+              <a:t>MANUTENÇÃO EM EQUIPAMENTO</a:t>
+            </a:r>
+          </a:p>
+          <a:p>
+            <a:pPr algn="ctr"/>
+            <a:r>
+              <a:rPr lang="pt-BR" sz="1200" b="1" dirty="0"/>
+              <a:t> NÃO LIGUE</a:t>
+            </a:r>
+          </a:p>
+        </p:txBody>
+      </p:sp>
+      <p:sp>
+        <p:nvSpPr>
+          <p:cNvPr id="106" name="Retângulo 105"/>
+          <p:cNvSpPr/>
+          <p:nvPr/>
+        </p:nvSpPr>
+        <p:spPr>
+          <a:xfrm>
+            <a:off x="6315458" y="1900545"/>
+            <a:ext cx="1929580" cy="646331"/>
+          </a:xfrm>
+          <a:prstGeom prst="rect">
+            <a:avLst/>
+          </a:prstGeom>
+        </p:spPr>
+        <p:txBody>
+          <a:bodyPr wrap="square">
+            <a:spAutoFit/>
+          </a:bodyPr>
+          <a:lstStyle/>
+          <a:p>
+            <a:pPr algn="ctr"/>
+            <a:r>
+              <a:rPr lang="pt-BR" sz="1200" b="1" dirty="0"/>
+              <a:t>MANUTENÇÃO EM EQUIPAMENTO</a:t>
+            </a:r>
+          </a:p>
+          <a:p>
+            <a:pPr algn="ctr"/>
+            <a:r>
+              <a:rPr lang="pt-BR" sz="1200" b="1" dirty="0"/>
+              <a:t> NÃO LIGUE</a:t>
+            </a:r>
+          </a:p>
+        </p:txBody>
+      </p:sp>
+      <p:sp>
+        <p:nvSpPr>
+          <p:cNvPr id="107" name="Retângulo 106"/>
+          <p:cNvSpPr/>
+          <p:nvPr/>
+        </p:nvSpPr>
+        <p:spPr>
+          <a:xfrm>
+            <a:off x="703250" y="1876144"/>
+            <a:ext cx="1929580" cy="646331"/>
+          </a:xfrm>
+          <a:prstGeom prst="rect">
+            <a:avLst/>
+          </a:prstGeom>
+        </p:spPr>
+        <p:txBody>
+          <a:bodyPr wrap="square">
+            <a:spAutoFit/>
+          </a:bodyPr>
+          <a:lstStyle/>
+          <a:p>
+            <a:pPr algn="ctr"/>
+            <a:r>
+              <a:rPr lang="pt-BR" sz="1200" b="1" dirty="0"/>
+              <a:t>MANUTENÇÃO EM EQUIPAMENTO</a:t>
+            </a:r>
+          </a:p>
+          <a:p>
+            <a:pPr algn="ctr"/>
+            <a:r>
+              <a:rPr lang="pt-BR" sz="1200" b="1" dirty="0"/>
+              <a:t> NÃO LIGUE</a:t>
+            </a:r>
+          </a:p>
+        </p:txBody>
+      </p:sp>
+      <p:sp>
+        <p:nvSpPr>
+          <p:cNvPr id="108" name="CARD3_NOME"/>
+          <p:cNvSpPr/>
+          <p:nvPr/>
+        </p:nvSpPr>
+        <p:spPr>
+          <a:xfrm>
+            <a:off x="4615336" y="2540195"/>
+            <a:ext cx="1582282" cy="215444"/>
+          </a:xfrm>
+          <a:prstGeom prst="rect">
+            <a:avLst/>
+          </a:prstGeom>
+        </p:spPr>
+        <p:txBody>
+          <a:bodyPr wrap="square">
+            <a:spAutoFit/>
+          </a:bodyPr>
+          <a:lstStyle/>
+          <a:p>
+            <a:r>
+              <a:rPr lang="pt-BR" sz="800" dirty="0"/>
+              <a:t>{{NOME}}</a:t>
+            </a:r>
+            <a:endParaRPr lang="pt-BR" sz="1200" dirty="0"/>
+          </a:p>
+        </p:txBody>
+      </p:sp>
+      <p:sp>
+        <p:nvSpPr>
           <p:cNvPr id="15" name="CARD4_NOME"/>
           <p:cNvSpPr/>
           <p:nvPr/>
@@ -5793,7 +5793,7 @@
           </a:prstGeom>
         </p:spPr>
         <p:txBody>
-          <a:bodyPr wrap="none">
+          <a:bodyPr wrap="square">
             <a:spAutoFit/>
           </a:bodyPr>
           <a:lstStyle/>
@@ -5897,7 +5897,7 @@
           </a:prstGeom>
         </p:spPr>
         <p:txBody>
-          <a:bodyPr wrap="none">
+          <a:bodyPr wrap="square">
             <a:spAutoFit/>
           </a:bodyPr>
           <a:lstStyle/>
@@ -5926,7 +5926,7 @@
           </a:prstGeom>
         </p:spPr>
         <p:txBody>
-          <a:bodyPr wrap="none">
+          <a:bodyPr wrap="square">
             <a:spAutoFit/>
           </a:bodyPr>
           <a:lstStyle/>
@@ -5954,7 +5954,7 @@
           </a:prstGeom>
         </p:spPr>
         <p:txBody>
-          <a:bodyPr wrap="none">
+          <a:bodyPr wrap="square">
             <a:spAutoFit/>
           </a:bodyPr>
           <a:lstStyle/>
@@ -6137,7 +6137,7 @@
       </p:pic>
       <p:pic>
         <p:nvPicPr>
-          <p:cNvPr id="83" name="CARD7_FOTO" descr="image.jpg">
+          <p:cNvPr id="83" name="CARD8_FOTO" descr="image.jpg">
             <a:extLst>
               <a:ext uri="{FF2B5EF4-FFF2-40B4-BE49-F238E27FC236}">
                 <a16:creationId xmlns:a16="http://schemas.microsoft.com/office/drawing/2014/main" id="{7C2EDF45-4F5E-402F-92A8-2BCF80D8EBED}"/>
@@ -6167,7 +6167,7 @@
       </p:pic>
       <p:sp>
         <p:nvSpPr>
-          <p:cNvPr id="87" name="CARD7_NOME">
+          <p:cNvPr id="87" name="CARD8_NOME">
             <a:extLst>
               <a:ext uri="{FF2B5EF4-FFF2-40B4-BE49-F238E27FC236}">
                 <a16:creationId xmlns:a16="http://schemas.microsoft.com/office/drawing/2014/main" id="{C46FDD3C-CA35-457D-853F-EDA346493698}"/>
@@ -6187,7 +6187,7 @@
           </a:prstGeom>
         </p:spPr>
         <p:txBody>
-          <a:bodyPr wrap="none">
+          <a:bodyPr wrap="square">
             <a:spAutoFit/>
           </a:bodyPr>
           <a:lstStyle/>
@@ -6202,7 +6202,7 @@
       </p:sp>
       <p:sp>
         <p:nvSpPr>
-          <p:cNvPr id="88" name="CARD7_FUNCAO">
+          <p:cNvPr id="88" name="CARD8_FUNCAO">
             <a:extLst>
               <a:ext uri="{FF2B5EF4-FFF2-40B4-BE49-F238E27FC236}">
                 <a16:creationId xmlns:a16="http://schemas.microsoft.com/office/drawing/2014/main" id="{6E19A8D6-403C-475C-85F4-0AF859622ECB}"/>
@@ -6222,7 +6222,7 @@
           </a:prstGeom>
         </p:spPr>
         <p:txBody>
-          <a:bodyPr wrap="none">
+          <a:bodyPr wrap="square">
             <a:spAutoFit/>
           </a:bodyPr>
           <a:lstStyle/>
@@ -6236,7 +6236,7 @@
       </p:sp>
       <p:sp>
         <p:nvSpPr>
-          <p:cNvPr id="104" name="CARD7_TELEFONE">
+          <p:cNvPr id="104" name="CARD8_TELEFONE">
             <a:extLst>
               <a:ext uri="{FF2B5EF4-FFF2-40B4-BE49-F238E27FC236}">
                 <a16:creationId xmlns:a16="http://schemas.microsoft.com/office/drawing/2014/main" id="{5B59F489-94E9-456F-9A37-87E8E41C15AE}"/>
@@ -6256,7 +6256,7 @@
           </a:prstGeom>
         </p:spPr>
         <p:txBody>
-          <a:bodyPr wrap="none">
+          <a:bodyPr wrap="square">
             <a:spAutoFit/>
           </a:bodyPr>
           <a:lstStyle/>

</xml_diff>